<commit_message>
feat(deck): embed high-resolution infographics, architectural diagrams and workflow charts into SIH 2026 presentation
</commit_message>
<xml_diff>
--- a/SwasthyaSetu_SIH2026_Idea_Presentation.pptx
+++ b/SwasthyaSetu_SIH2026_Idea_Presentation.pptx
@@ -6188,16 +6188,127 @@
           </a:p>
         </p:txBody>
       </p:sp>
-      <p:sp>
-        <p:nvSpPr>
-          <p:cNvPr id="15363" name="Rounded Rectangle 15362"/>
+      <p:pic>
+        <p:nvPicPr>
+          <p:cNvPr id="15363" name="Picture 15362" descr="referral_workflow_infographic.jpg"/>
+          <p:cNvPicPr>
+            <a:picLocks noChangeAspect="1"/>
+          </p:cNvPicPr>
+          <p:nvPr/>
+        </p:nvPicPr>
+        <p:blipFill>
+          <a:blip r:embed="rId4"/>
+          <a:stretch>
+            <a:fillRect/>
+          </a:stretch>
+        </p:blipFill>
+        <p:spPr>
+          <a:xfrm>
+            <a:off x="612648" y="1444752"/>
+            <a:ext cx="6035040" cy="3392424"/>
+          </a:xfrm>
+          <a:prstGeom prst="rect">
+            <a:avLst/>
+          </a:prstGeom>
+        </p:spPr>
+      </p:pic>
+      <p:sp>
+        <p:nvSpPr>
+          <p:cNvPr id="15364" name="Rounded Rectangle 15363"/>
           <p:cNvSpPr/>
           <p:nvPr/>
         </p:nvSpPr>
         <p:spPr>
           <a:xfrm>
-            <a:off x="612648" y="1417320"/>
-            <a:ext cx="5349240" cy="1325880"/>
+            <a:off x="612648" y="4919472"/>
+            <a:ext cx="6035040" cy="1298448"/>
+          </a:xfrm>
+          <a:prstGeom prst="roundRect">
+            <a:avLst/>
+          </a:prstGeom>
+          <a:solidFill>
+            <a:srgbClr val="0F172A"/>
+          </a:solidFill>
+          <a:ln w="19050">
+            <a:solidFill>
+              <a:srgbClr val="0D9488"/>
+            </a:solidFill>
+          </a:ln>
+        </p:spPr>
+        <p:style>
+          <a:lnRef idx="1">
+            <a:schemeClr val="accent1"/>
+          </a:lnRef>
+          <a:fillRef idx="3">
+            <a:schemeClr val="accent1"/>
+          </a:fillRef>
+          <a:effectRef idx="2">
+            <a:schemeClr val="accent1"/>
+          </a:effectRef>
+          <a:fontRef idx="minor">
+            <a:schemeClr val="lt1"/>
+          </a:fontRef>
+        </p:style>
+        <p:txBody>
+          <a:bodyPr rtlCol="0" anchor="ctr" wrap="square" lIns="109728" rIns="109728" tIns="73152"/>
+          <a:lstStyle/>
+          <a:p>
+            <a:pPr algn="ctr">
+              <a:defRPr sz="919" b="1">
+                <a:solidFill>
+                  <a:srgbClr val="FFFFFF"/>
+                </a:solidFill>
+                <a:latin typeface="Arial"/>
+              </a:defRPr>
+            </a:pPr>
+            <a:r>
+              <a:t>KEY NOVELTY: The ONLY Closed-Loop Public Health Referral Platform</a:t>
+            </a:r>
+          </a:p>
+          <a:p>
+            <a:pPr>
+              <a:spcBef>
+                <a:spcPts val="200"/>
+              </a:spcBef>
+              <a:defRPr sz="780">
+                <a:solidFill>
+                  <a:srgbClr val="E2E8F0"/>
+                </a:solidFill>
+                <a:latin typeface="Arial"/>
+              </a:defRPr>
+            </a:pPr>
+            <a:r>
+              <a:t>• Bidirectional Care Visibility: Village Sub-Centre (AAM) ➔ PHC ➔ CHC ➔ District Hospital ➔ ASHA Counter-Referral.</a:t>
+            </a:r>
+          </a:p>
+          <a:p>
+            <a:pPr>
+              <a:spcBef>
+                <a:spcPts val="200"/>
+              </a:spcBef>
+              <a:defRPr sz="780">
+                <a:solidFill>
+                  <a:srgbClr val="E2E8F0"/>
+                </a:solidFill>
+                <a:latin typeface="Arial"/>
+              </a:defRPr>
+            </a:pPr>
+            <a:r>
+              <a:t>• National Digital Health Rails: Native ABDM UHI (FHIR R4), ABHA creation, and auto-triage for MJPJAY cashless coverage.</a:t>
+            </a:r>
+          </a:p>
+        </p:txBody>
+      </p:sp>
+      <p:sp>
+        <p:nvSpPr>
+          <p:cNvPr id="15365" name="Rounded Rectangle 15364"/>
+          <p:cNvSpPr/>
+          <p:nvPr/>
+        </p:nvSpPr>
+        <p:spPr>
+          <a:xfrm>
+            <a:off x="6812280" y="1444752"/>
+            <a:ext cx="4773168" cy="1051560"/>
           </a:xfrm>
           <a:prstGeom prst="roundRect">
             <a:avLst/>
@@ -6226,11 +6337,11 @@
           </a:fontRef>
         </p:style>
         <p:txBody>
-          <a:bodyPr rtlCol="0" anchor="ctr" wrap="square" lIns="128016" rIns="128016" tIns="73152"/>
+          <a:bodyPr rtlCol="0" anchor="ctr" wrap="square" tIns="54864"/>
           <a:lstStyle/>
           <a:p>
             <a:pPr algn="ctr">
-              <a:defRPr sz="1000" b="1">
+              <a:defRPr sz="880" b="1">
                 <a:solidFill>
                   <a:srgbClr val="E11D48"/>
                 </a:solidFill>
@@ -6238,15 +6349,15 @@
               </a:defRPr>
             </a:pPr>
             <a:r>
-              <a:t>THE PROBLEM: The Rural Healthcare 'Clinical Black Hole'</a:t>
+              <a:t>THE PROBLEM: The Rural 'Clinical Black Hole'</a:t>
             </a:r>
           </a:p>
           <a:p>
             <a:pPr>
               <a:spcBef>
-                <a:spcPts val="150"/>
+                <a:spcPts val="100"/>
               </a:spcBef>
-              <a:defRPr sz="819">
+              <a:defRPr sz="720">
                 <a:solidFill>
                   <a:srgbClr val="1E293B"/>
                 </a:solidFill>
@@ -6254,15 +6365,15 @@
               </a:defRPr>
             </a:pPr>
             <a:r>
-              <a:t>• 150,000+ blind paper referrals weekly across India's 31,000 PHCs without receiving notice.</a:t>
+              <a:t>• 150,000+ blind paper referrals weekly across India's 31,000 PHCs without confirmation.</a:t>
             </a:r>
           </a:p>
           <a:p>
             <a:pPr>
               <a:spcBef>
-                <a:spcPts val="150"/>
+                <a:spcPts val="100"/>
               </a:spcBef>
-              <a:defRPr sz="819">
+              <a:defRPr sz="720">
                 <a:solidFill>
                   <a:srgbClr val="1E293B"/>
                 </a:solidFill>
@@ -6270,15 +6381,15 @@
               </a:defRPr>
             </a:pPr>
             <a:r>
-              <a:t>• 48.2% Referral Drop-out: Patients travel 40-80 km only to find specialists absent or beds full.</a:t>
+              <a:t>• 48.2% drop-out: Patients travel 40-80 km only to find specialists absent or beds full.</a:t>
             </a:r>
           </a:p>
           <a:p>
             <a:pPr>
               <a:spcBef>
-                <a:spcPts val="150"/>
+                <a:spcPts val="100"/>
               </a:spcBef>
-              <a:defRPr sz="819">
+              <a:defRPr sz="720">
                 <a:solidFill>
                   <a:srgbClr val="1E293B"/>
                 </a:solidFill>
@@ -6286,21 +6397,21 @@
               </a:defRPr>
             </a:pPr>
             <a:r>
-              <a:t>• Zero Counter-Referral: Discharges never reach village ASHAs, causing fatal relapses &amp; OOPE debt.</a:t>
-            </a:r>
-          </a:p>
-        </p:txBody>
-      </p:sp>
-      <p:sp>
-        <p:nvSpPr>
-          <p:cNvPr id="15364" name="Rounded Rectangle 15363"/>
+              <a:t>• Zero Counter-Referral: Discharges never reach village ASHAs, causing fatal relapses.</a:t>
+            </a:r>
+          </a:p>
+        </p:txBody>
+      </p:sp>
+      <p:sp>
+        <p:nvSpPr>
+          <p:cNvPr id="15366" name="Rounded Rectangle 15365"/>
           <p:cNvSpPr/>
           <p:nvPr/>
         </p:nvSpPr>
         <p:spPr>
           <a:xfrm>
-            <a:off x="6236208" y="1417320"/>
-            <a:ext cx="5349240" cy="1325880"/>
+            <a:off x="6812280" y="2560320"/>
+            <a:ext cx="4773168" cy="1024128"/>
           </a:xfrm>
           <a:prstGeom prst="roundRect">
             <a:avLst/>
@@ -6329,11 +6440,11 @@
           </a:fontRef>
         </p:style>
         <p:txBody>
-          <a:bodyPr rtlCol="0" anchor="ctr" wrap="square" lIns="128016" rIns="128016" tIns="73152"/>
+          <a:bodyPr rtlCol="0" anchor="ctr" wrap="square" tIns="54864"/>
           <a:lstStyle/>
           <a:p>
             <a:pPr algn="ctr">
-              <a:defRPr sz="1000" b="1">
+              <a:defRPr sz="880" b="1">
                 <a:solidFill>
                   <a:srgbClr val="0D9488"/>
                 </a:solidFill>
@@ -6347,9 +6458,9 @@
           <a:p>
             <a:pPr>
               <a:spcBef>
-                <a:spcPts val="150"/>
+                <a:spcPts val="100"/>
               </a:spcBef>
-              <a:defRPr sz="819">
+              <a:defRPr sz="720">
                 <a:solidFill>
                   <a:srgbClr val="1E293B"/>
                 </a:solidFill>
@@ -6357,15 +6468,15 @@
               </a:defRPr>
             </a:pPr>
             <a:r>
-              <a:t>• End-to-End Care Continuity: Connects Sub-Centre (AAM) -&gt; PHC -&gt; CHC -&gt; District Hospital.</a:t>
+              <a:t>• End-to-End Orchestration: Real-time patient tracking from village clinic to tertiary discharge.</a:t>
             </a:r>
           </a:p>
           <a:p>
             <a:pPr>
               <a:spcBef>
-                <a:spcPts val="150"/>
+                <a:spcPts val="100"/>
               </a:spcBef>
-              <a:defRPr sz="819">
+              <a:defRPr sz="720">
                 <a:solidFill>
                   <a:srgbClr val="1E293B"/>
                 </a:solidFill>
@@ -6373,15 +6484,15 @@
               </a:defRPr>
             </a:pPr>
             <a:r>
-              <a:t>• Care Readiness Verification: Verifies 6-factor readiness before travel + auto-reroutes if blocked.</a:t>
+              <a:t>• Care Readiness Verification: 6-factor check ensures specialist, ICU bed, &amp; diagnostics ready.</a:t>
             </a:r>
           </a:p>
           <a:p>
             <a:pPr>
               <a:spcBef>
-                <a:spcPts val="150"/>
+                <a:spcPts val="100"/>
               </a:spcBef>
-              <a:defRPr sz="819">
+              <a:defRPr sz="720">
                 <a:solidFill>
                   <a:srgbClr val="1E293B"/>
                 </a:solidFill>
@@ -6389,29 +6500,29 @@
               </a:defRPr>
             </a:pPr>
             <a:r>
-              <a:t>• Zero-Typing &amp; Zero-Data-Loss: Multilingual voice intake in Marathi + offline-first sync queue.</a:t>
-            </a:r>
-          </a:p>
-        </p:txBody>
-      </p:sp>
-      <p:sp>
-        <p:nvSpPr>
-          <p:cNvPr id="15365" name="Rounded Rectangle 15364"/>
+              <a:t>• Zero-Data-Loss: Multilingual Marathi voice intake + offline-first encrypted sync.</a:t>
+            </a:r>
+          </a:p>
+        </p:txBody>
+      </p:sp>
+      <p:sp>
+        <p:nvSpPr>
+          <p:cNvPr id="15367" name="Rounded Rectangle 15366"/>
           <p:cNvSpPr/>
           <p:nvPr/>
         </p:nvSpPr>
         <p:spPr>
           <a:xfrm>
-            <a:off x="612648" y="2852928"/>
-            <a:ext cx="2606040" cy="3108960"/>
+            <a:off x="6812280" y="3648456"/>
+            <a:ext cx="4773168" cy="2569464"/>
           </a:xfrm>
           <a:prstGeom prst="roundRect">
             <a:avLst/>
           </a:prstGeom>
           <a:solidFill>
-            <a:srgbClr val="EFF6FF"/>
+            <a:srgbClr val="F8FAFC"/>
           </a:solidFill>
-          <a:ln w="15240">
+          <a:ln w="12700">
             <a:solidFill>
               <a:srgbClr val="2563EB"/>
             </a:solidFill>
@@ -6432,537 +6543,119 @@
           </a:fontRef>
         </p:style>
         <p:txBody>
-          <a:bodyPr rtlCol="0" anchor="ctr" wrap="square" lIns="109728" rIns="109728" tIns="91440"/>
+          <a:bodyPr rtlCol="0" anchor="ctr" wrap="square" tIns="54864"/>
           <a:lstStyle/>
           <a:p>
             <a:pPr algn="ctr">
-              <a:defRPr sz="950" b="1">
-                <a:solidFill>
-                  <a:srgbClr val="2563EB"/>
+              <a:defRPr sz="880" b="1">
+                <a:solidFill>
+                  <a:srgbClr val="0F172A"/>
                 </a:solidFill>
                 <a:latin typeface="Arial"/>
               </a:defRPr>
             </a:pPr>
             <a:r>
-              <a:t>Pillar 1: Voice-First Vernacular</a:t>
+              <a:t>4 ARCHITECTURAL PILLARS (Frontline to Tertiary)</a:t>
             </a:r>
           </a:p>
           <a:p>
             <a:pPr>
               <a:spcBef>
-                <a:spcPts val="350"/>
+                <a:spcPts val="250"/>
               </a:spcBef>
             </a:pPr>
             <a:r>
-              <a:rPr sz="800" b="1">
+              <a:rPr sz="730" b="1">
                 <a:solidFill>
                   <a:srgbClr val="0F172A"/>
                 </a:solidFill>
                 <a:latin typeface="Arial"/>
               </a:rPr>
-              <a:t>Tech:</a:t>
-            </a:r>
-            <a:r>
-              <a:rPr sz="780" b="0">
+              <a:t>• Pillar 1 (Voice-First):</a:t>
+            </a:r>
+            <a:r>
+              <a:rPr sz="710">
                 <a:solidFill>
                   <a:srgbClr val="1E293B"/>
                 </a:solidFill>
                 <a:latin typeface="Arial"/>
               </a:rPr>
-              <a:t> Bhashini Indic STT / NMT</a:t>
+              <a:t> Bhashini Marathi/Hindi speech-to-text; 50s intake on 2GB RAM phones.</a:t>
             </a:r>
           </a:p>
           <a:p>
             <a:pPr>
               <a:spcBef>
-                <a:spcPts val="350"/>
+                <a:spcPts val="250"/>
               </a:spcBef>
             </a:pPr>
             <a:r>
-              <a:rPr sz="800" b="1">
+              <a:rPr sz="730" b="1">
                 <a:solidFill>
                   <a:srgbClr val="0F172A"/>
                 </a:solidFill>
                 <a:latin typeface="Arial"/>
               </a:rPr>
-              <a:t>Action:</a:t>
-            </a:r>
-            <a:r>
-              <a:rPr sz="780" b="0">
+              <a:t>• Pillar 2 (Offline-First):</a:t>
+            </a:r>
+            <a:r>
+              <a:rPr sz="710">
                 <a:solidFill>
                   <a:srgbClr val="1E293B"/>
                 </a:solidFill>
                 <a:latin typeface="Arial"/>
               </a:rPr>
-              <a:t> Spoken Marathi/Hindi symptom dictation (e.g. 'छातीत दुखणे, धाप लागणे').</a:t>
+              <a:t> SQLite/WatermelonDB CRDTs store 5,000+ records in monsoon blindspots.</a:t>
             </a:r>
           </a:p>
           <a:p>
             <a:pPr>
               <a:spcBef>
-                <a:spcPts val="350"/>
+                <a:spcPts val="250"/>
               </a:spcBef>
             </a:pPr>
             <a:r>
-              <a:rPr sz="800" b="1">
+              <a:rPr sz="730" b="1">
                 <a:solidFill>
                   <a:srgbClr val="0F172A"/>
                 </a:solidFill>
                 <a:latin typeface="Arial"/>
               </a:rPr>
-              <a:t>Impact:</a:t>
-            </a:r>
-            <a:r>
-              <a:rPr sz="780" b="0">
+              <a:t>• Pillar 3 (One-Trip Care):</a:t>
+            </a:r>
+            <a:r>
+              <a:rPr sz="710">
                 <a:solidFill>
                   <a:srgbClr val="1E293B"/>
                 </a:solidFill>
                 <a:latin typeface="Arial"/>
               </a:rPr>
-              <a:t> Eliminates complex English text entry; reduces ASHA logging from 8m to 50s on basic Android Go phones.</a:t>
-            </a:r>
-          </a:p>
-        </p:txBody>
-      </p:sp>
-      <p:sp>
-        <p:nvSpPr>
-          <p:cNvPr id="15366" name="Rounded Rectangle 15365"/>
-          <p:cNvSpPr/>
-          <p:nvPr/>
-        </p:nvSpPr>
-        <p:spPr>
-          <a:xfrm>
-            <a:off x="3401568" y="2852928"/>
-            <a:ext cx="2606040" cy="3108960"/>
-          </a:xfrm>
-          <a:prstGeom prst="roundRect">
-            <a:avLst/>
-          </a:prstGeom>
-          <a:solidFill>
-            <a:srgbClr val="F0FDFA"/>
-          </a:solidFill>
-          <a:ln w="15240">
-            <a:solidFill>
-              <a:srgbClr val="0D9488"/>
-            </a:solidFill>
-          </a:ln>
-        </p:spPr>
-        <p:style>
-          <a:lnRef idx="1">
-            <a:schemeClr val="accent1"/>
-          </a:lnRef>
-          <a:fillRef idx="3">
-            <a:schemeClr val="accent1"/>
-          </a:fillRef>
-          <a:effectRef idx="2">
-            <a:schemeClr val="accent1"/>
-          </a:effectRef>
-          <a:fontRef idx="minor">
-            <a:schemeClr val="lt1"/>
-          </a:fontRef>
-        </p:style>
-        <p:txBody>
-          <a:bodyPr rtlCol="0" anchor="ctr" wrap="square" lIns="109728" rIns="109728" tIns="91440"/>
-          <a:lstStyle/>
-          <a:p>
-            <a:pPr algn="ctr">
-              <a:defRPr sz="950" b="1">
-                <a:solidFill>
-                  <a:srgbClr val="0D9488"/>
-                </a:solidFill>
-                <a:latin typeface="Arial"/>
-              </a:defRPr>
-            </a:pPr>
-            <a:r>
-              <a:t>Pillar 2: Patient Offline-First</a:t>
+              <a:t> Bundles specialist OPD, ECG/CBC labs &amp; transit into a single visit.</a:t>
             </a:r>
           </a:p>
           <a:p>
             <a:pPr>
               <a:spcBef>
-                <a:spcPts val="350"/>
+                <a:spcPts val="250"/>
               </a:spcBef>
             </a:pPr>
             <a:r>
-              <a:rPr sz="800" b="1">
+              <a:rPr sz="730" b="1">
                 <a:solidFill>
                   <a:srgbClr val="0F172A"/>
                 </a:solidFill>
                 <a:latin typeface="Arial"/>
               </a:rPr>
-              <a:t>Tech:</a:t>
-            </a:r>
-            <a:r>
-              <a:rPr sz="780" b="0">
+              <a:t>• Pillar 4 (Readiness WOW):</a:t>
+            </a:r>
+            <a:r>
+              <a:rPr sz="710">
                 <a:solidFill>
                   <a:srgbClr val="1E293B"/>
                 </a:solidFill>
                 <a:latin typeface="Arial"/>
               </a:rPr>
-              <a:t> SQLite / WatermelonDB CRDTs</a:t>
-            </a:r>
-          </a:p>
-          <a:p>
-            <a:pPr>
-              <a:spcBef>
-                <a:spcPts val="350"/>
-              </a:spcBef>
-            </a:pPr>
-            <a:r>
-              <a:rPr sz="800" b="1">
-                <a:solidFill>
-                  <a:srgbClr val="0F172A"/>
-                </a:solidFill>
-                <a:latin typeface="Arial"/>
-              </a:rPr>
-              <a:t>Action:</a:t>
-            </a:r>
-            <a:r>
-              <a:rPr sz="780" b="0">
-                <a:solidFill>
-                  <a:srgbClr val="1E293B"/>
-                </a:solidFill>
-                <a:latin typeface="Arial"/>
-              </a:rPr>
-              <a:t> Local encrypted queue storing 5,000+ patient records on mobile device.</a:t>
-            </a:r>
-          </a:p>
-          <a:p>
-            <a:pPr>
-              <a:spcBef>
-                <a:spcPts val="350"/>
-              </a:spcBef>
-            </a:pPr>
-            <a:r>
-              <a:rPr sz="800" b="1">
-                <a:solidFill>
-                  <a:srgbClr val="0F172A"/>
-                </a:solidFill>
-                <a:latin typeface="Arial"/>
-              </a:rPr>
-              <a:t>Impact:</a:t>
-            </a:r>
-            <a:r>
-              <a:rPr sz="780" b="0">
-                <a:solidFill>
-                  <a:srgbClr val="1E293B"/>
-                </a:solidFill>
-                <a:latin typeface="Arial"/>
-              </a:rPr>
-              <a:t> Guaranteed zero data loss in rural monsoon network dead zones; automatic background sync on reconnect.</a:t>
-            </a:r>
-          </a:p>
-        </p:txBody>
-      </p:sp>
-      <p:sp>
-        <p:nvSpPr>
-          <p:cNvPr id="15367" name="Rounded Rectangle 15366"/>
-          <p:cNvSpPr/>
-          <p:nvPr/>
-        </p:nvSpPr>
-        <p:spPr>
-          <a:xfrm>
-            <a:off x="6190488" y="2852928"/>
-            <a:ext cx="2606040" cy="3108960"/>
-          </a:xfrm>
-          <a:prstGeom prst="roundRect">
-            <a:avLst/>
-          </a:prstGeom>
-          <a:solidFill>
-            <a:srgbClr val="F8FAFC"/>
-          </a:solidFill>
-          <a:ln w="15240">
-            <a:solidFill>
-              <a:srgbClr val="0F172A"/>
-            </a:solidFill>
-          </a:ln>
-        </p:spPr>
-        <p:style>
-          <a:lnRef idx="1">
-            <a:schemeClr val="accent1"/>
-          </a:lnRef>
-          <a:fillRef idx="3">
-            <a:schemeClr val="accent1"/>
-          </a:fillRef>
-          <a:effectRef idx="2">
-            <a:schemeClr val="accent1"/>
-          </a:effectRef>
-          <a:fontRef idx="minor">
-            <a:schemeClr val="lt1"/>
-          </a:fontRef>
-        </p:style>
-        <p:txBody>
-          <a:bodyPr rtlCol="0" anchor="ctr" wrap="square" lIns="109728" rIns="109728" tIns="91440"/>
-          <a:lstStyle/>
-          <a:p>
-            <a:pPr algn="ctr">
-              <a:defRPr sz="950" b="1">
-                <a:solidFill>
-                  <a:srgbClr val="0F172A"/>
-                </a:solidFill>
-                <a:latin typeface="Arial"/>
-              </a:defRPr>
-            </a:pPr>
-            <a:r>
-              <a:t>Pillar 3: Coordinated One-Trip</a:t>
-            </a:r>
-          </a:p>
-          <a:p>
-            <a:pPr>
-              <a:spcBef>
-                <a:spcPts val="350"/>
-              </a:spcBef>
-            </a:pPr>
-            <a:r>
-              <a:rPr sz="800" b="1">
-                <a:solidFill>
-                  <a:srgbClr val="0F172A"/>
-                </a:solidFill>
-                <a:latin typeface="Arial"/>
-              </a:rPr>
-              <a:t>Tech:</a:t>
-            </a:r>
-            <a:r>
-              <a:rPr sz="780" b="0">
-                <a:solidFill>
-                  <a:srgbClr val="1E293B"/>
-                </a:solidFill>
-                <a:latin typeface="Arial"/>
-              </a:rPr>
-              <a:t> Care Bundle Decision Model</a:t>
-            </a:r>
-          </a:p>
-          <a:p>
-            <a:pPr>
-              <a:spcBef>
-                <a:spcPts val="350"/>
-              </a:spcBef>
-            </a:pPr>
-            <a:r>
-              <a:rPr sz="800" b="1">
-                <a:solidFill>
-                  <a:srgbClr val="0F172A"/>
-                </a:solidFill>
-                <a:latin typeface="Arial"/>
-              </a:rPr>
-              <a:t>Action:</a:t>
-            </a:r>
-            <a:r>
-              <a:rPr sz="780" b="0">
-                <a:solidFill>
-                  <a:srgbClr val="1E293B"/>
-                </a:solidFill>
-                <a:latin typeface="Arial"/>
-              </a:rPr>
-              <a:t> Bundles specialty consultation, on-site diagnostics (ECG, CBC), and documents.</a:t>
-            </a:r>
-          </a:p>
-          <a:p>
-            <a:pPr>
-              <a:spcBef>
-                <a:spcPts val="350"/>
-              </a:spcBef>
-            </a:pPr>
-            <a:r>
-              <a:rPr sz="800" b="1">
-                <a:solidFill>
-                  <a:srgbClr val="0F172A"/>
-                </a:solidFill>
-                <a:latin typeface="Arial"/>
-              </a:rPr>
-              <a:t>Impact:</a:t>
-            </a:r>
-            <a:r>
-              <a:rPr sz="780" b="0">
-                <a:solidFill>
-                  <a:srgbClr val="1E293B"/>
-                </a:solidFill>
-                <a:latin typeface="Arial"/>
-              </a:rPr>
-              <a:t> Stops the 'ping-pong' referral cycle; cuts travel &amp; catastrophic out-of-pocket costs by &gt;60%.</a:t>
-            </a:r>
-          </a:p>
-        </p:txBody>
-      </p:sp>
-      <p:sp>
-        <p:nvSpPr>
-          <p:cNvPr id="15368" name="Rounded Rectangle 15367"/>
-          <p:cNvSpPr/>
-          <p:nvPr/>
-        </p:nvSpPr>
-        <p:spPr>
-          <a:xfrm>
-            <a:off x="8979408" y="2852928"/>
-            <a:ext cx="2606040" cy="3108960"/>
-          </a:xfrm>
-          <a:prstGeom prst="roundRect">
-            <a:avLst/>
-          </a:prstGeom>
-          <a:solidFill>
-            <a:srgbClr val="FFF1F2"/>
-          </a:solidFill>
-          <a:ln w="15240">
-            <a:solidFill>
-              <a:srgbClr val="E11D48"/>
-            </a:solidFill>
-          </a:ln>
-        </p:spPr>
-        <p:style>
-          <a:lnRef idx="1">
-            <a:schemeClr val="accent1"/>
-          </a:lnRef>
-          <a:fillRef idx="3">
-            <a:schemeClr val="accent1"/>
-          </a:fillRef>
-          <a:effectRef idx="2">
-            <a:schemeClr val="accent1"/>
-          </a:effectRef>
-          <a:fontRef idx="minor">
-            <a:schemeClr val="lt1"/>
-          </a:fontRef>
-        </p:style>
-        <p:txBody>
-          <a:bodyPr rtlCol="0" anchor="ctr" wrap="square" lIns="109728" rIns="109728" tIns="91440"/>
-          <a:lstStyle/>
-          <a:p>
-            <a:pPr algn="ctr">
-              <a:defRPr sz="950" b="1">
-                <a:solidFill>
-                  <a:srgbClr val="E11D48"/>
-                </a:solidFill>
-                <a:latin typeface="Arial"/>
-              </a:defRPr>
-            </a:pPr>
-            <a:r>
-              <a:t>Pillar 4: Care Readiness (WOW)</a:t>
-            </a:r>
-          </a:p>
-          <a:p>
-            <a:pPr>
-              <a:spcBef>
-                <a:spcPts val="350"/>
-              </a:spcBef>
-            </a:pPr>
-            <a:r>
-              <a:rPr sz="800" b="1">
-                <a:solidFill>
-                  <a:srgbClr val="0F172A"/>
-                </a:solidFill>
-                <a:latin typeface="Arial"/>
-              </a:rPr>
-              <a:t>Tech:</a:t>
-            </a:r>
-            <a:r>
-              <a:rPr sz="780" b="0">
-                <a:solidFill>
-                  <a:srgbClr val="1E293B"/>
-                </a:solidFill>
-                <a:latin typeface="Arial"/>
-              </a:rPr>
-              <a:t> 6-Factor Decision Engine</a:t>
-            </a:r>
-          </a:p>
-          <a:p>
-            <a:pPr>
-              <a:spcBef>
-                <a:spcPts val="350"/>
-              </a:spcBef>
-            </a:pPr>
-            <a:r>
-              <a:rPr sz="800" b="1">
-                <a:solidFill>
-                  <a:srgbClr val="0F172A"/>
-                </a:solidFill>
-                <a:latin typeface="Arial"/>
-              </a:rPr>
-              <a:t>Action:</a:t>
-            </a:r>
-            <a:r>
-              <a:rPr sz="780" b="0">
-                <a:solidFill>
-                  <a:srgbClr val="1E293B"/>
-                </a:solidFill>
-                <a:latin typeface="Arial"/>
-              </a:rPr>
-              <a:t> Checks Doctor, Diagnostics, Equipment, ICU Beds (&lt;85%), and Docs before departure.</a:t>
-            </a:r>
-          </a:p>
-          <a:p>
-            <a:pPr>
-              <a:spcBef>
-                <a:spcPts val="350"/>
-              </a:spcBef>
-            </a:pPr>
-            <a:r>
-              <a:rPr sz="800" b="1">
-                <a:solidFill>
-                  <a:srgbClr val="0F172A"/>
-                </a:solidFill>
-                <a:latin typeface="Arial"/>
-              </a:rPr>
-              <a:t>Impact:</a:t>
-            </a:r>
-            <a:r>
-              <a:rPr sz="780" b="0">
-                <a:solidFill>
-                  <a:srgbClr val="1E293B"/>
-                </a:solidFill>
-                <a:latin typeface="Arial"/>
-              </a:rPr>
-              <a:t> Stops door refusals; dynamic rerouting recovers referral if hospital becomes unavailable.</a:t>
-            </a:r>
-          </a:p>
-        </p:txBody>
-      </p:sp>
-      <p:sp>
-        <p:nvSpPr>
-          <p:cNvPr id="15369" name="Rectangle 15368"/>
-          <p:cNvSpPr/>
-          <p:nvPr/>
-        </p:nvSpPr>
-        <p:spPr>
-          <a:xfrm>
-            <a:off x="612648" y="6035040"/>
-            <a:ext cx="10972800" cy="256032"/>
-          </a:xfrm>
-          <a:prstGeom prst="rect">
-            <a:avLst/>
-          </a:prstGeom>
-          <a:solidFill>
-            <a:srgbClr val="0F172A"/>
-          </a:solidFill>
-          <a:ln>
-            <a:noFill/>
-          </a:ln>
-        </p:spPr>
-        <p:style>
-          <a:lnRef idx="1">
-            <a:schemeClr val="accent1"/>
-          </a:lnRef>
-          <a:fillRef idx="3">
-            <a:schemeClr val="accent1"/>
-          </a:fillRef>
-          <a:effectRef idx="2">
-            <a:schemeClr val="accent1"/>
-          </a:effectRef>
-          <a:fontRef idx="minor">
-            <a:schemeClr val="lt1"/>
-          </a:fontRef>
-        </p:style>
-        <p:txBody>
-          <a:bodyPr rtlCol="0" anchor="ctr"/>
-          <a:lstStyle/>
-          <a:p>
-            <a:pPr algn="ctr">
-              <a:defRPr sz="819" b="1">
-                <a:solidFill>
-                  <a:srgbClr val="FFFFFF"/>
-                </a:solidFill>
-                <a:latin typeface="Arial"/>
-              </a:defRPr>
-            </a:pPr>
-            <a:r>
-              <a:t>KEY NOVELTY: The ONLY system providing Closed-Loop Tracking (Village -&gt; Hospital -&gt; ASHA Counter-Referral) + ABDM UHI &amp; MJPJAY Integration</a:t>
+              <a:t> Algorithmic pre-departure verification of doctor presence &amp; ICU beds (&lt;85%).</a:t>
             </a:r>
           </a:p>
         </p:txBody>
@@ -7284,137 +6977,46 @@
           </a:p>
         </p:txBody>
       </p:sp>
-      <p:sp>
-        <p:nvSpPr>
-          <p:cNvPr id="17411" name="Rounded Rectangle 17410"/>
-          <p:cNvSpPr/>
+      <p:pic>
+        <p:nvPicPr>
+          <p:cNvPr id="17411" name="Picture 17410" descr="platform_architecture_infographic.jpg"/>
+          <p:cNvPicPr>
+            <a:picLocks noChangeAspect="1"/>
+          </p:cNvPicPr>
           <p:nvPr/>
-        </p:nvSpPr>
+        </p:nvPicPr>
+        <p:blipFill>
+          <a:blip r:embed="rId4"/>
+          <a:stretch>
+            <a:fillRect/>
+          </a:stretch>
+        </p:blipFill>
         <p:spPr>
           <a:xfrm>
             <a:off x="612648" y="1444752"/>
-            <a:ext cx="1691640" cy="1188720"/>
+            <a:ext cx="5943600" cy="3346704"/>
+          </a:xfrm>
+          <a:prstGeom prst="rect">
+            <a:avLst/>
+          </a:prstGeom>
+        </p:spPr>
+      </p:pic>
+      <p:sp>
+        <p:nvSpPr>
+          <p:cNvPr id="17412" name="Rounded Rectangle 17411"/>
+          <p:cNvSpPr/>
+          <p:nvPr/>
+        </p:nvSpPr>
+        <p:spPr>
+          <a:xfrm>
+            <a:off x="612648" y="4864608"/>
+            <a:ext cx="5943600" cy="1353312"/>
           </a:xfrm>
           <a:prstGeom prst="roundRect">
             <a:avLst/>
           </a:prstGeom>
           <a:solidFill>
-            <a:srgbClr val="EFF6FF"/>
-          </a:solidFill>
-          <a:ln w="15240">
-            <a:solidFill>
-              <a:srgbClr val="2563EB"/>
-            </a:solidFill>
-          </a:ln>
-        </p:spPr>
-        <p:style>
-          <a:lnRef idx="1">
-            <a:schemeClr val="accent1"/>
-          </a:lnRef>
-          <a:fillRef idx="3">
-            <a:schemeClr val="accent1"/>
-          </a:fillRef>
-          <a:effectRef idx="2">
-            <a:schemeClr val="accent1"/>
-          </a:effectRef>
-          <a:fontRef idx="minor">
-            <a:schemeClr val="lt1"/>
-          </a:fontRef>
-        </p:style>
-        <p:txBody>
-          <a:bodyPr rtlCol="0" anchor="ctr" wrap="square" lIns="73152" rIns="73152" tIns="73152"/>
-          <a:lstStyle/>
-          <a:p>
-            <a:pPr algn="ctr">
-              <a:defRPr sz="819" b="1">
-                <a:solidFill>
-                  <a:srgbClr val="2563EB"/>
-                </a:solidFill>
-                <a:latin typeface="Arial"/>
-              </a:defRPr>
-            </a:pPr>
-            <a:r>
-              <a:t>01. INTAKE &amp; TRIAGE</a:t>
-            </a:r>
-          </a:p>
-          <a:p>
-            <a:pPr algn="ctr">
-              <a:spcBef>
-                <a:spcPts val="200"/>
-              </a:spcBef>
-              <a:defRPr sz="740">
-                <a:solidFill>
-                  <a:srgbClr val="1E293B"/>
-                </a:solidFill>
-                <a:latin typeface="Arial"/>
-              </a:defRPr>
-            </a:pPr>
-            <a:r>
-              <a:t>ASHA speaks Marathi;</a:t>
-            </a:r>
-            <a:br/>
-            <a:r>
-              <a:t>Bhashini STT + OCR slip</a:t>
-            </a:r>
-            <a:br/>
-            <a:r>
-              <a:t>ingests vitals offline.</a:t>
-            </a:r>
-          </a:p>
-        </p:txBody>
-      </p:sp>
-      <p:sp>
-        <p:nvSpPr>
-          <p:cNvPr id="17412" name="TextBox 17411"/>
-          <p:cNvSpPr txBox="1"/>
-          <p:nvPr/>
-        </p:nvSpPr>
-        <p:spPr>
-          <a:xfrm>
-            <a:off x="2322576" y="1810512"/>
-            <a:ext cx="128016" cy="365760"/>
-          </a:xfrm>
-          <a:prstGeom prst="rect">
-            <a:avLst/>
-          </a:prstGeom>
-          <a:noFill/>
-        </p:spPr>
-        <p:txBody>
-          <a:bodyPr wrap="none" lIns="0" rIns="0" tIns="0" bIns="0">
-            <a:spAutoFit/>
-          </a:bodyPr>
-          <a:lstStyle/>
-          <a:p>
-            <a:pPr>
-              <a:defRPr sz="1100" b="1">
-                <a:solidFill>
-                  <a:srgbClr val="64748B"/>
-                </a:solidFill>
-                <a:latin typeface="Arial"/>
-              </a:defRPr>
-            </a:pPr>
-            <a:r>
-              <a:t>➔</a:t>
-            </a:r>
-          </a:p>
-        </p:txBody>
-      </p:sp>
-      <p:sp>
-        <p:nvSpPr>
-          <p:cNvPr id="17413" name="Rounded Rectangle 17412"/>
-          <p:cNvSpPr/>
-          <p:nvPr/>
-        </p:nvSpPr>
-        <p:spPr>
-          <a:xfrm>
-            <a:off x="2468880" y="1444752"/>
-            <a:ext cx="1691640" cy="1188720"/>
-          </a:xfrm>
-          <a:prstGeom prst="roundRect">
-            <a:avLst/>
-          </a:prstGeom>
-          <a:solidFill>
-            <a:srgbClr val="F0FDFA"/>
+            <a:srgbClr val="F8FAFC"/>
           </a:solidFill>
           <a:ln w="15240">
             <a:solidFill>
@@ -7437,11 +7039,11 @@
           </a:fontRef>
         </p:style>
         <p:txBody>
-          <a:bodyPr rtlCol="0" anchor="ctr" wrap="square" lIns="73152" rIns="73152" tIns="73152"/>
+          <a:bodyPr rtlCol="0" anchor="ctr" wrap="square" lIns="109728" rIns="109728" tIns="73152"/>
           <a:lstStyle/>
           <a:p>
             <a:pPr algn="ctr">
-              <a:defRPr sz="819" b="1">
+              <a:defRPr sz="880" b="1">
                 <a:solidFill>
                   <a:srgbClr val="0D9488"/>
                 </a:solidFill>
@@ -7449,15 +7051,15 @@
               </a:defRPr>
             </a:pPr>
             <a:r>
-              <a:t>02. CLINICAL CDSS</a:t>
-            </a:r>
-          </a:p>
-          <a:p>
-            <a:pPr algn="ctr">
+              <a:t>6-STAGE CARE ORCHESTRATION PIPELINE (WORKING PROTOTYPE)</a:t>
+            </a:r>
+          </a:p>
+          <a:p>
+            <a:pPr>
               <a:spcBef>
-                <a:spcPts val="200"/>
+                <a:spcPts val="120"/>
               </a:spcBef>
-              <a:defRPr sz="740">
+              <a:defRPr sz="690">
                 <a:solidFill>
                   <a:srgbClr val="1E293B"/>
                 </a:solidFill>
@@ -7465,114 +7067,47 @@
               </a:defRPr>
             </a:pPr>
             <a:r>
-              <a:t>ICMR/WHO rule engine</a:t>
-            </a:r>
-            <a:br/>
-            <a:r>
-              <a:t>flags Red/Amber triage;</a:t>
-            </a:r>
-            <a:br/>
-            <a:r>
-              <a:t>builds Care Bundle.</a:t>
-            </a:r>
-          </a:p>
-        </p:txBody>
-      </p:sp>
-      <p:sp>
-        <p:nvSpPr>
-          <p:cNvPr id="17414" name="TextBox 17413"/>
-          <p:cNvSpPr txBox="1"/>
-          <p:nvPr/>
-        </p:nvSpPr>
-        <p:spPr>
-          <a:xfrm>
-            <a:off x="4178808" y="1810512"/>
-            <a:ext cx="128016" cy="365760"/>
-          </a:xfrm>
-          <a:prstGeom prst="rect">
-            <a:avLst/>
-          </a:prstGeom>
-          <a:noFill/>
-        </p:spPr>
-        <p:txBody>
-          <a:bodyPr wrap="none" lIns="0" rIns="0" tIns="0" bIns="0">
-            <a:spAutoFit/>
-          </a:bodyPr>
-          <a:lstStyle/>
+              <a:t>• 01. Intake (Voice): ASHA speaks Marathi; Bhashini STT + OCR slip ingests vitals offline.</a:t>
+            </a:r>
+          </a:p>
           <a:p>
             <a:pPr>
-              <a:defRPr sz="1100" b="1">
-                <a:solidFill>
-                  <a:srgbClr val="64748B"/>
+              <a:spcBef>
+                <a:spcPts val="120"/>
+              </a:spcBef>
+              <a:defRPr sz="690">
+                <a:solidFill>
+                  <a:srgbClr val="1E293B"/>
                 </a:solidFill>
                 <a:latin typeface="Arial"/>
               </a:defRPr>
             </a:pPr>
             <a:r>
-              <a:t>➔</a:t>
-            </a:r>
-          </a:p>
-        </p:txBody>
-      </p:sp>
-      <p:sp>
-        <p:nvSpPr>
-          <p:cNvPr id="17415" name="Rounded Rectangle 17414"/>
-          <p:cNvSpPr/>
-          <p:nvPr/>
-        </p:nvSpPr>
-        <p:spPr>
-          <a:xfrm>
-            <a:off x="4325112" y="1444752"/>
-            <a:ext cx="1691640" cy="1188720"/>
-          </a:xfrm>
-          <a:prstGeom prst="roundRect">
-            <a:avLst/>
-          </a:prstGeom>
-          <a:solidFill>
-            <a:srgbClr val="FEF2F2"/>
-          </a:solidFill>
-          <a:ln w="15240">
-            <a:solidFill>
-              <a:srgbClr val="E11D48"/>
-            </a:solidFill>
-          </a:ln>
-        </p:spPr>
-        <p:style>
-          <a:lnRef idx="1">
-            <a:schemeClr val="accent1"/>
-          </a:lnRef>
-          <a:fillRef idx="3">
-            <a:schemeClr val="accent1"/>
-          </a:fillRef>
-          <a:effectRef idx="2">
-            <a:schemeClr val="accent1"/>
-          </a:effectRef>
-          <a:fontRef idx="minor">
-            <a:schemeClr val="lt1"/>
-          </a:fontRef>
-        </p:style>
-        <p:txBody>
-          <a:bodyPr rtlCol="0" anchor="ctr" wrap="square" lIns="73152" rIns="73152" tIns="73152"/>
-          <a:lstStyle/>
-          <a:p>
-            <a:pPr algn="ctr">
-              <a:defRPr sz="819" b="1">
-                <a:solidFill>
-                  <a:srgbClr val="E11D48"/>
+              <a:t>• 02. CDSS &amp; Bundle: ICMR/WHO CDSS flags triage severity (Red/Amber) &amp; bundles care.</a:t>
+            </a:r>
+          </a:p>
+          <a:p>
+            <a:pPr>
+              <a:spcBef>
+                <a:spcPts val="120"/>
+              </a:spcBef>
+              <a:defRPr sz="690">
+                <a:solidFill>
+                  <a:srgbClr val="1E293B"/>
                 </a:solidFill>
                 <a:latin typeface="Arial"/>
               </a:defRPr>
             </a:pPr>
             <a:r>
-              <a:t>03. CARE READINESS</a:t>
-            </a:r>
-          </a:p>
-          <a:p>
-            <a:pPr algn="ctr">
+              <a:t>• 03. Readiness Check: Algorithmic 6-factor check (Doctor, Beds, Diagnostics) at destination.</a:t>
+            </a:r>
+          </a:p>
+          <a:p>
+            <a:pPr>
               <a:spcBef>
-                <a:spcPts val="200"/>
+                <a:spcPts val="120"/>
               </a:spcBef>
-              <a:defRPr sz="740">
+              <a:defRPr sz="690">
                 <a:solidFill>
                   <a:srgbClr val="1E293B"/>
                 </a:solidFill>
@@ -7580,375 +7115,54 @@
               </a:defRPr>
             </a:pPr>
             <a:r>
-              <a:t>6-factor check (Beds,</a:t>
-            </a:r>
-            <a:br/>
-            <a:r>
-              <a:t>Doctor, Diagnostics)</a:t>
-            </a:r>
-            <a:br/>
-            <a:r>
-              <a:t>at destination facility.</a:t>
-            </a:r>
-          </a:p>
-        </p:txBody>
-      </p:sp>
-      <p:sp>
-        <p:nvSpPr>
-          <p:cNvPr id="17416" name="TextBox 17415"/>
-          <p:cNvSpPr txBox="1"/>
-          <p:nvPr/>
-        </p:nvSpPr>
-        <p:spPr>
-          <a:xfrm>
-            <a:off x="6035040" y="1810512"/>
-            <a:ext cx="128016" cy="365760"/>
-          </a:xfrm>
-          <a:prstGeom prst="rect">
-            <a:avLst/>
-          </a:prstGeom>
-          <a:noFill/>
-        </p:spPr>
-        <p:txBody>
-          <a:bodyPr wrap="none" lIns="0" rIns="0" tIns="0" bIns="0">
-            <a:spAutoFit/>
-          </a:bodyPr>
-          <a:lstStyle/>
+              <a:t>• 04. Dynamic Routing: Spatial PostGIS Haversine matrix routes patient; sends DLT SMS token.</a:t>
+            </a:r>
+          </a:p>
           <a:p>
             <a:pPr>
-              <a:defRPr sz="1100" b="1">
-                <a:solidFill>
-                  <a:srgbClr val="64748B"/>
+              <a:spcBef>
+                <a:spcPts val="120"/>
+              </a:spcBef>
+              <a:defRPr sz="690">
+                <a:solidFill>
+                  <a:srgbClr val="1E293B"/>
                 </a:solidFill>
                 <a:latin typeface="Arial"/>
               </a:defRPr>
             </a:pPr>
             <a:r>
-              <a:t>➔</a:t>
-            </a:r>
-          </a:p>
-        </p:txBody>
-      </p:sp>
-      <p:sp>
-        <p:nvSpPr>
-          <p:cNvPr id="17417" name="Rounded Rectangle 17416"/>
-          <p:cNvSpPr/>
-          <p:nvPr/>
-        </p:nvSpPr>
-        <p:spPr>
-          <a:xfrm>
-            <a:off x="6181344" y="1444752"/>
-            <a:ext cx="1691640" cy="1188720"/>
-          </a:xfrm>
-          <a:prstGeom prst="roundRect">
-            <a:avLst/>
-          </a:prstGeom>
-          <a:solidFill>
-            <a:srgbClr val="F8FAFC"/>
-          </a:solidFill>
-          <a:ln w="15240">
-            <a:solidFill>
-              <a:srgbClr val="0F172A"/>
-            </a:solidFill>
-          </a:ln>
-        </p:spPr>
-        <p:style>
-          <a:lnRef idx="1">
-            <a:schemeClr val="accent1"/>
-          </a:lnRef>
-          <a:fillRef idx="3">
-            <a:schemeClr val="accent1"/>
-          </a:fillRef>
-          <a:effectRef idx="2">
-            <a:schemeClr val="accent1"/>
-          </a:effectRef>
-          <a:fontRef idx="minor">
-            <a:schemeClr val="lt1"/>
-          </a:fontRef>
-        </p:style>
-        <p:txBody>
-          <a:bodyPr rtlCol="0" anchor="ctr" wrap="square" lIns="73152" rIns="73152" tIns="73152"/>
-          <a:lstStyle/>
-          <a:p>
-            <a:pPr algn="ctr">
-              <a:defRPr sz="819" b="1">
-                <a:solidFill>
-                  <a:srgbClr val="0F172A"/>
+              <a:t>• 05. Fast-Track OPD: Hospital pre-notified; patient scans QR token, bypassing 3.5h queues.</a:t>
+            </a:r>
+          </a:p>
+          <a:p>
+            <a:pPr>
+              <a:spcBef>
+                <a:spcPts val="120"/>
+              </a:spcBef>
+              <a:defRPr sz="690">
+                <a:solidFill>
+                  <a:srgbClr val="1E293B"/>
                 </a:solidFill>
                 <a:latin typeface="Arial"/>
               </a:defRPr>
             </a:pPr>
             <a:r>
-              <a:t>04. DYNAMIC ROUTING</a:t>
-            </a:r>
-          </a:p>
-          <a:p>
-            <a:pPr algn="ctr">
-              <a:spcBef>
-                <a:spcPts val="200"/>
-              </a:spcBef>
-              <a:defRPr sz="740">
-                <a:solidFill>
-                  <a:srgbClr val="1E293B"/>
-                </a:solidFill>
-                <a:latin typeface="Arial"/>
-              </a:defRPr>
-            </a:pPr>
-            <a:r>
-              <a:t>Spatial Haversine matrix</a:t>
-            </a:r>
-            <a:br/>
-            <a:r>
-              <a:t>picks best hospital;</a:t>
-            </a:r>
-            <a:br/>
-            <a:r>
-              <a:t>DLT SMS token sent.</a:t>
-            </a:r>
-          </a:p>
-        </p:txBody>
-      </p:sp>
-      <p:sp>
-        <p:nvSpPr>
-          <p:cNvPr id="17418" name="TextBox 17417"/>
-          <p:cNvSpPr txBox="1"/>
-          <p:nvPr/>
-        </p:nvSpPr>
-        <p:spPr>
-          <a:xfrm>
-            <a:off x="7891272" y="1810512"/>
-            <a:ext cx="128016" cy="365760"/>
-          </a:xfrm>
-          <a:prstGeom prst="rect">
-            <a:avLst/>
-          </a:prstGeom>
-          <a:noFill/>
-        </p:spPr>
-        <p:txBody>
-          <a:bodyPr wrap="none" lIns="0" rIns="0" tIns="0" bIns="0">
-            <a:spAutoFit/>
-          </a:bodyPr>
-          <a:lstStyle/>
-          <a:p>
-            <a:pPr>
-              <a:defRPr sz="1100" b="1">
-                <a:solidFill>
-                  <a:srgbClr val="64748B"/>
-                </a:solidFill>
-                <a:latin typeface="Arial"/>
-              </a:defRPr>
-            </a:pPr>
-            <a:r>
-              <a:t>➔</a:t>
-            </a:r>
-          </a:p>
-        </p:txBody>
-      </p:sp>
-      <p:sp>
-        <p:nvSpPr>
-          <p:cNvPr id="17419" name="Rounded Rectangle 17418"/>
-          <p:cNvSpPr/>
-          <p:nvPr/>
-        </p:nvSpPr>
-        <p:spPr>
-          <a:xfrm>
-            <a:off x="8037576" y="1444752"/>
-            <a:ext cx="1691640" cy="1188720"/>
-          </a:xfrm>
-          <a:prstGeom prst="roundRect">
-            <a:avLst/>
-          </a:prstGeom>
-          <a:solidFill>
-            <a:srgbClr val="EFF6FF"/>
-          </a:solidFill>
-          <a:ln w="15240">
-            <a:solidFill>
-              <a:srgbClr val="2563EB"/>
-            </a:solidFill>
-          </a:ln>
-        </p:spPr>
-        <p:style>
-          <a:lnRef idx="1">
-            <a:schemeClr val="accent1"/>
-          </a:lnRef>
-          <a:fillRef idx="3">
-            <a:schemeClr val="accent1"/>
-          </a:fillRef>
-          <a:effectRef idx="2">
-            <a:schemeClr val="accent1"/>
-          </a:effectRef>
-          <a:fontRef idx="minor">
-            <a:schemeClr val="lt1"/>
-          </a:fontRef>
-        </p:style>
-        <p:txBody>
-          <a:bodyPr rtlCol="0" anchor="ctr" wrap="square" lIns="73152" rIns="73152" tIns="73152"/>
-          <a:lstStyle/>
-          <a:p>
-            <a:pPr algn="ctr">
-              <a:defRPr sz="819" b="1">
-                <a:solidFill>
-                  <a:srgbClr val="2563EB"/>
-                </a:solidFill>
-                <a:latin typeface="Arial"/>
-              </a:defRPr>
-            </a:pPr>
-            <a:r>
-              <a:t>05. FAST-TRACK OPD</a:t>
-            </a:r>
-          </a:p>
-          <a:p>
-            <a:pPr algn="ctr">
-              <a:spcBef>
-                <a:spcPts val="200"/>
-              </a:spcBef>
-              <a:defRPr sz="740">
-                <a:solidFill>
-                  <a:srgbClr val="1E293B"/>
-                </a:solidFill>
-                <a:latin typeface="Arial"/>
-              </a:defRPr>
-            </a:pPr>
-            <a:r>
-              <a:t>Hospital pre-notified;</a:t>
-            </a:r>
-            <a:br/>
-            <a:r>
-              <a:t>patient scans QR token;</a:t>
-            </a:r>
-            <a:br/>
-            <a:r>
-              <a:t>bypasses 3.5h line.</a:t>
-            </a:r>
-          </a:p>
-        </p:txBody>
-      </p:sp>
-      <p:sp>
-        <p:nvSpPr>
-          <p:cNvPr id="17420" name="TextBox 17419"/>
-          <p:cNvSpPr txBox="1"/>
-          <p:nvPr/>
-        </p:nvSpPr>
-        <p:spPr>
-          <a:xfrm>
-            <a:off x="9747504" y="1810512"/>
-            <a:ext cx="128016" cy="365760"/>
-          </a:xfrm>
-          <a:prstGeom prst="rect">
-            <a:avLst/>
-          </a:prstGeom>
-          <a:noFill/>
-        </p:spPr>
-        <p:txBody>
-          <a:bodyPr wrap="none" lIns="0" rIns="0" tIns="0" bIns="0">
-            <a:spAutoFit/>
-          </a:bodyPr>
-          <a:lstStyle/>
-          <a:p>
-            <a:pPr>
-              <a:defRPr sz="1100" b="1">
-                <a:solidFill>
-                  <a:srgbClr val="64748B"/>
-                </a:solidFill>
-                <a:latin typeface="Arial"/>
-              </a:defRPr>
-            </a:pPr>
-            <a:r>
-              <a:t>➔</a:t>
-            </a:r>
-          </a:p>
-        </p:txBody>
-      </p:sp>
-      <p:sp>
-        <p:nvSpPr>
-          <p:cNvPr id="17421" name="Rounded Rectangle 17420"/>
-          <p:cNvSpPr/>
-          <p:nvPr/>
-        </p:nvSpPr>
-        <p:spPr>
-          <a:xfrm>
-            <a:off x="9893808" y="1444752"/>
-            <a:ext cx="1691640" cy="1188720"/>
-          </a:xfrm>
-          <a:prstGeom prst="roundRect">
-            <a:avLst/>
-          </a:prstGeom>
-          <a:solidFill>
-            <a:srgbClr val="ECFDF5"/>
-          </a:solidFill>
-          <a:ln w="15240">
-            <a:solidFill>
-              <a:srgbClr val="10B981"/>
-            </a:solidFill>
-          </a:ln>
-        </p:spPr>
-        <p:style>
-          <a:lnRef idx="1">
-            <a:schemeClr val="accent1"/>
-          </a:lnRef>
-          <a:fillRef idx="3">
-            <a:schemeClr val="accent1"/>
-          </a:fillRef>
-          <a:effectRef idx="2">
-            <a:schemeClr val="accent1"/>
-          </a:effectRef>
-          <a:fontRef idx="minor">
-            <a:schemeClr val="lt1"/>
-          </a:fontRef>
-        </p:style>
-        <p:txBody>
-          <a:bodyPr rtlCol="0" anchor="ctr" wrap="square" lIns="73152" rIns="73152" tIns="73152"/>
-          <a:lstStyle/>
-          <a:p>
-            <a:pPr algn="ctr">
-              <a:defRPr sz="819" b="1">
-                <a:solidFill>
-                  <a:srgbClr val="10B981"/>
-                </a:solidFill>
-                <a:latin typeface="Arial"/>
-              </a:defRPr>
-            </a:pPr>
-            <a:r>
-              <a:t>06. COUNTER-REFERRAL</a:t>
-            </a:r>
-          </a:p>
-          <a:p>
-            <a:pPr algn="ctr">
-              <a:spcBef>
-                <a:spcPts val="200"/>
-              </a:spcBef>
-              <a:defRPr sz="740">
-                <a:solidFill>
-                  <a:srgbClr val="1E293B"/>
-                </a:solidFill>
-                <a:latin typeface="Arial"/>
-              </a:defRPr>
-            </a:pPr>
-            <a:r>
-              <a:t>E-discharge auto-creates</a:t>
-            </a:r>
-            <a:br/>
-            <a:r>
-              <a:t>home follow-up task on</a:t>
-            </a:r>
-            <a:br/>
-            <a:r>
-              <a:t>village ASHA app.</a:t>
+              <a:t>• 06. Counter-Referral: Tertiary discharge auto-creates home follow-up task on village ASHA app.</a:t>
             </a:r>
           </a:p>
         </p:txBody>
       </p:sp>
       <p:graphicFrame>
         <p:nvGraphicFramePr>
-          <p:cNvPr id="17422" name="Table 17421"/>
+          <p:cNvPr id="17413" name="Table 17412"/>
           <p:cNvGraphicFramePr>
             <a:graphicFrameLocks noGrp="1"/>
           </p:cNvGraphicFramePr>
           <p:nvPr/>
         </p:nvGraphicFramePr>
         <p:xfrm>
-          <a:off x="612648" y="2761488"/>
-          <a:ext cx="10972800" cy="3474720"/>
+          <a:off x="6693408" y="1444752"/>
+          <a:ext cx="4892039" cy="4773168"/>
         </p:xfrm>
         <a:graphic>
           <a:graphicData uri="http://schemas.openxmlformats.org/drawingml/2006/table">
@@ -7957,18 +7171,18 @@
                 <a:tableStyleId>{5C22544A-7EE6-4342-B048-85BDC9FD1C3A}</a:tableStyleId>
               </a:tblPr>
               <a:tblGrid>
-                <a:gridCol w="2011680"/>
-                <a:gridCol w="3931920"/>
-                <a:gridCol w="5029200"/>
+                <a:gridCol w="1234440"/>
+                <a:gridCol w="1874519"/>
+                <a:gridCol w="1783080"/>
               </a:tblGrid>
-              <a:tr h="496388">
+              <a:tr h="681881">
                 <a:tc>
                   <a:txBody>
                     <a:bodyPr/>
                     <a:lstStyle/>
                     <a:p>
                       <a:pPr>
-                        <a:defRPr sz="850" b="1">
+                        <a:defRPr sz="780" b="1">
                           <a:solidFill>
                             <a:srgbClr val="FFFFFF"/>
                           </a:solidFill>
@@ -7976,7 +7190,7 @@
                         </a:defRPr>
                       </a:pPr>
                       <a:r>
-                        <a:t>Architecture Layer</a:t>
+                        <a:t>Layer</a:t>
                       </a:r>
                     </a:p>
                   </a:txBody>
@@ -7992,7 +7206,7 @@
                     <a:lstStyle/>
                     <a:p>
                       <a:pPr>
-                        <a:defRPr sz="850" b="1">
+                        <a:defRPr sz="780" b="1">
                           <a:solidFill>
                             <a:srgbClr val="FFFFFF"/>
                           </a:solidFill>
@@ -8000,7 +7214,7 @@
                         </a:defRPr>
                       </a:pPr>
                       <a:r>
-                        <a:t>Production Technology Stack</a:t>
+                        <a:t>Production Tech Stack</a:t>
                       </a:r>
                     </a:p>
                   </a:txBody>
@@ -8016,7 +7230,7 @@
                     <a:lstStyle/>
                     <a:p>
                       <a:pPr>
-                        <a:defRPr sz="850" b="1">
+                        <a:defRPr sz="780" b="1">
                           <a:solidFill>
                             <a:srgbClr val="FFFFFF"/>
                           </a:solidFill>
@@ -8024,7 +7238,7 @@
                         </a:defRPr>
                       </a:pPr>
                       <a:r>
-                        <a:t>Engineering &amp; Operational Rationale</a:t>
+                        <a:t>Engineering Rationale</a:t>
                       </a:r>
                     </a:p>
                   </a:txBody>
@@ -8035,14 +7249,14 @@
                   </a:tcPr>
                 </a:tc>
               </a:tr>
-              <a:tr h="496388">
+              <a:tr h="681881">
                 <a:tc>
                   <a:txBody>
                     <a:bodyPr/>
                     <a:lstStyle/>
                     <a:p>
                       <a:pPr>
-                        <a:defRPr sz="800" b="1">
+                        <a:defRPr sz="720" b="1">
                           <a:solidFill>
                             <a:srgbClr val="0F172A"/>
                           </a:solidFill>
@@ -8050,7 +7264,7 @@
                         </a:defRPr>
                       </a:pPr>
                       <a:r>
-                        <a:t>Mobile &amp; Web Client</a:t>
+                        <a:t>Mobile &amp; Web</a:t>
                       </a:r>
                     </a:p>
                   </a:txBody>
@@ -8066,7 +7280,7 @@
                     <a:lstStyle/>
                     <a:p>
                       <a:pPr>
-                        <a:defRPr sz="800">
+                        <a:defRPr sz="720">
                           <a:solidFill>
                             <a:srgbClr val="1E293B"/>
                           </a:solidFill>
@@ -8090,7 +7304,7 @@
                     <a:lstStyle/>
                     <a:p>
                       <a:pPr>
-                        <a:defRPr sz="800">
+                        <a:defRPr sz="720">
                           <a:solidFill>
                             <a:srgbClr val="1E293B"/>
                           </a:solidFill>
@@ -8098,7 +7312,7 @@
                         </a:defRPr>
                       </a:pPr>
                       <a:r>
-                        <a:t>Ultra-lightweight (&lt;15 MB APK), offline-ready, runs smoothly on 2GB RAM phones.</a:t>
+                        <a:t>Ultra-lightweight (&lt;15 MB APK), offline-ready, runs on 2GB RAM phones.</a:t>
                       </a:r>
                     </a:p>
                   </a:txBody>
@@ -8109,14 +7323,14 @@
                   </a:tcPr>
                 </a:tc>
               </a:tr>
-              <a:tr h="496388">
+              <a:tr h="681881">
                 <a:tc>
                   <a:txBody>
                     <a:bodyPr/>
                     <a:lstStyle/>
                     <a:p>
                       <a:pPr>
-                        <a:defRPr sz="800" b="1">
+                        <a:defRPr sz="720" b="1">
                           <a:solidFill>
                             <a:srgbClr val="0F172A"/>
                           </a:solidFill>
@@ -8124,7 +7338,7 @@
                         </a:defRPr>
                       </a:pPr>
                       <a:r>
-                        <a:t>API Gateway &amp; Services</a:t>
+                        <a:t>API Gateway</a:t>
                       </a:r>
                     </a:p>
                   </a:txBody>
@@ -8140,7 +7354,7 @@
                     <a:lstStyle/>
                     <a:p>
                       <a:pPr>
-                        <a:defRPr sz="800">
+                        <a:defRPr sz="720">
                           <a:solidFill>
                             <a:srgbClr val="1E293B"/>
                           </a:solidFill>
@@ -8148,7 +7362,7 @@
                         </a:defRPr>
                       </a:pPr>
                       <a:r>
-                        <a:t>NestJS (Node.js 20+) Modular Microservices Architecture</a:t>
+                        <a:t>NestJS (Node.js 20+) Modular Microservices</a:t>
                       </a:r>
                     </a:p>
                   </a:txBody>
@@ -8164,7 +7378,7 @@
                     <a:lstStyle/>
                     <a:p>
                       <a:pPr>
-                        <a:defRPr sz="800">
+                        <a:defRPr sz="720">
                           <a:solidFill>
                             <a:srgbClr val="1E293B"/>
                           </a:solidFill>
@@ -8172,7 +7386,7 @@
                         </a:defRPr>
                       </a:pPr>
                       <a:r>
-                        <a:t>High-throughput asynchronous REST/GraphQL gateway, JWT + Argon2 security, DLT SMS.</a:t>
+                        <a:t>High-throughput async REST/GraphQL, JWT + Argon2 security, DLT SMS.</a:t>
                       </a:r>
                     </a:p>
                   </a:txBody>
@@ -8183,14 +7397,14 @@
                   </a:tcPr>
                 </a:tc>
               </a:tr>
-              <a:tr h="496388">
+              <a:tr h="681881">
                 <a:tc>
                   <a:txBody>
                     <a:bodyPr/>
                     <a:lstStyle/>
                     <a:p>
                       <a:pPr>
-                        <a:defRPr sz="800" b="1">
+                        <a:defRPr sz="720" b="1">
                           <a:solidFill>
                             <a:srgbClr val="0F172A"/>
                           </a:solidFill>
@@ -8214,7 +7428,7 @@
                     <a:lstStyle/>
                     <a:p>
                       <a:pPr>
-                        <a:defRPr sz="800">
+                        <a:defRPr sz="720">
                           <a:solidFill>
                             <a:srgbClr val="1E293B"/>
                           </a:solidFill>
@@ -8222,7 +7436,7 @@
                         </a:defRPr>
                       </a:pPr>
                       <a:r>
-                        <a:t>PostgreSQL + PostGIS (Spatial) + Prisma ORM</a:t>
+                        <a:t>PostgreSQL 16 + PostGIS + Prisma ORM</a:t>
                       </a:r>
                     </a:p>
                   </a:txBody>
@@ -8238,7 +7452,7 @@
                     <a:lstStyle/>
                     <a:p>
                       <a:pPr>
-                        <a:defRPr sz="800">
+                        <a:defRPr sz="720">
                           <a:solidFill>
                             <a:srgbClr val="1E293B"/>
                           </a:solidFill>
@@ -8246,7 +7460,7 @@
                         </a:defRPr>
                       </a:pPr>
                       <a:r>
-                        <a:t>ACID transactions, spatial hospital distance queries, drive-time and load balancing.</a:t>
+                        <a:t>ACID transactions, spatial hospital distance queries, drive-time radius.</a:t>
                       </a:r>
                     </a:p>
                   </a:txBody>
@@ -8257,14 +7471,14 @@
                   </a:tcPr>
                 </a:tc>
               </a:tr>
-              <a:tr h="496388">
+              <a:tr h="681881">
                 <a:tc>
                   <a:txBody>
                     <a:bodyPr/>
                     <a:lstStyle/>
                     <a:p>
                       <a:pPr>
-                        <a:defRPr sz="800" b="1">
+                        <a:defRPr sz="720" b="1">
                           <a:solidFill>
                             <a:srgbClr val="0F172A"/>
                           </a:solidFill>
@@ -8272,7 +7486,7 @@
                         </a:defRPr>
                       </a:pPr>
                       <a:r>
-                        <a:t>Offline Storage &amp; Queue</a:t>
+                        <a:t>Offline &amp; Queue</a:t>
                       </a:r>
                     </a:p>
                   </a:txBody>
@@ -8288,7 +7502,7 @@
                     <a:lstStyle/>
                     <a:p>
                       <a:pPr>
-                        <a:defRPr sz="800">
+                        <a:defRPr sz="720">
                           <a:solidFill>
                             <a:srgbClr val="1E293B"/>
                           </a:solidFill>
@@ -8296,7 +7510,7 @@
                         </a:defRPr>
                       </a:pPr>
                       <a:r>
-                        <a:t>SQLite / WatermelonDB (CRDTs) + Redis BullMQ</a:t>
+                        <a:t>SQLite / WatermelonDB CRDTs + Redis BullMQ</a:t>
                       </a:r>
                     </a:p>
                   </a:txBody>
@@ -8312,7 +7526,7 @@
                     <a:lstStyle/>
                     <a:p>
                       <a:pPr>
-                        <a:defRPr sz="800">
+                        <a:defRPr sz="720">
                           <a:solidFill>
                             <a:srgbClr val="1E293B"/>
                           </a:solidFill>
@@ -8320,7 +7534,7 @@
                         </a:defRPr>
                       </a:pPr>
                       <a:r>
-                        <a:t>Guaranteed local storage during network drops; event-based background synchronization.</a:t>
+                        <a:t>Guaranteed local storage during network drops; background sync workers.</a:t>
                       </a:r>
                     </a:p>
                   </a:txBody>
@@ -8331,14 +7545,14 @@
                   </a:tcPr>
                 </a:tc>
               </a:tr>
-              <a:tr h="496388">
+              <a:tr h="681881">
                 <a:tc>
                   <a:txBody>
                     <a:bodyPr/>
                     <a:lstStyle/>
                     <a:p>
                       <a:pPr>
-                        <a:defRPr sz="800" b="1">
+                        <a:defRPr sz="720" b="1">
                           <a:solidFill>
                             <a:srgbClr val="0F172A"/>
                           </a:solidFill>
@@ -8346,7 +7560,7 @@
                         </a:defRPr>
                       </a:pPr>
                       <a:r>
-                        <a:t>AI &amp; Intelligence Layer</a:t>
+                        <a:t>AI &amp; Speech</a:t>
                       </a:r>
                     </a:p>
                   </a:txBody>
@@ -8362,7 +7576,7 @@
                     <a:lstStyle/>
                     <a:p>
                       <a:pPr>
-                        <a:defRPr sz="800">
+                        <a:defRPr sz="720">
                           <a:solidFill>
                             <a:srgbClr val="1E293B"/>
                           </a:solidFill>
@@ -8370,7 +7584,7 @@
                         </a:defRPr>
                       </a:pPr>
                       <a:r>
-                        <a:t>Gemini 2.5 Flash + Bhashini Indic STT + Tesseract OCR</a:t>
+                        <a:t>Gemini 2.5 Flash + Bhashini Indic STT + OCR</a:t>
                       </a:r>
                     </a:p>
                   </a:txBody>
@@ -8386,7 +7600,7 @@
                     <a:lstStyle/>
                     <a:p>
                       <a:pPr>
-                        <a:defRPr sz="800">
+                        <a:defRPr sz="720">
                           <a:solidFill>
                             <a:srgbClr val="1E293B"/>
                           </a:solidFill>
@@ -8394,7 +7608,7 @@
                         </a:defRPr>
                       </a:pPr>
                       <a:r>
-                        <a:t>Sub-second symptom extraction, vernacular Marathi voice dictation, scanned slip OCR.</a:t>
+                        <a:t>Sub-second symptom extraction, vernacular Marathi voice dictation.</a:t>
                       </a:r>
                     </a:p>
                   </a:txBody>
@@ -8405,14 +7619,14 @@
                   </a:tcPr>
                 </a:tc>
               </a:tr>
-              <a:tr h="496392">
+              <a:tr h="681882">
                 <a:tc>
                   <a:txBody>
                     <a:bodyPr/>
                     <a:lstStyle/>
                     <a:p>
                       <a:pPr>
-                        <a:defRPr sz="800" b="1">
+                        <a:defRPr sz="720" b="1">
                           <a:solidFill>
                             <a:srgbClr val="0F172A"/>
                           </a:solidFill>
@@ -8436,7 +7650,7 @@
                     <a:lstStyle/>
                     <a:p>
                       <a:pPr>
-                        <a:defRPr sz="800">
+                        <a:defRPr sz="720">
                           <a:solidFill>
                             <a:srgbClr val="1E293B"/>
                           </a:solidFill>
@@ -8444,7 +7658,7 @@
                         </a:defRPr>
                       </a:pPr>
                       <a:r>
-                        <a:t>ABDM Gateway (ABHA, HFR, HPR), FHIR R4, DPDP Act 2023</a:t>
+                        <a:t>ABDM Gateway (ABHA, HFR), FHIR R4, DPDP Act</a:t>
                       </a:r>
                     </a:p>
                   </a:txBody>
@@ -8460,7 +7674,7 @@
                     <a:lstStyle/>
                     <a:p>
                       <a:pPr>
-                        <a:defRPr sz="800">
+                        <a:defRPr sz="720">
                           <a:solidFill>
                             <a:srgbClr val="1E293B"/>
                           </a:solidFill>
@@ -8468,7 +7682,7 @@
                         </a:defRPr>
                       </a:pPr>
                       <a:r>
-                        <a:t>National Health Authority compliant, encrypted health bundles, verifiable patient consent.</a:t>
+                        <a:t>National Health Authority compliant, encrypted health bundles, patient consent.</a:t>
                       </a:r>
                     </a:p>
                   </a:txBody>
@@ -8898,16 +8112,40 @@
           </a:p>
         </p:txBody>
       </p:sp>
-      <p:sp>
-        <p:nvSpPr>
-          <p:cNvPr id="17411" name="Rounded Rectangle 17410"/>
-          <p:cNvSpPr/>
+      <p:pic>
+        <p:nvPicPr>
+          <p:cNvPr id="17411" name="Picture 17410" descr="feasibility_pillars_infographic.jpg"/>
+          <p:cNvPicPr>
+            <a:picLocks noChangeAspect="1"/>
+          </p:cNvPicPr>
           <p:nvPr/>
-        </p:nvSpPr>
+        </p:nvPicPr>
+        <p:blipFill>
+          <a:blip r:embed="rId4"/>
+          <a:stretch>
+            <a:fillRect/>
+          </a:stretch>
+        </p:blipFill>
         <p:spPr>
           <a:xfrm>
             <a:off x="612648" y="1444752"/>
-            <a:ext cx="4663440" cy="1508760"/>
+            <a:ext cx="5486400" cy="3090672"/>
+          </a:xfrm>
+          <a:prstGeom prst="rect">
+            <a:avLst/>
+          </a:prstGeom>
+        </p:spPr>
+      </p:pic>
+      <p:sp>
+        <p:nvSpPr>
+          <p:cNvPr id="17412" name="Rounded Rectangle 17411"/>
+          <p:cNvSpPr/>
+          <p:nvPr/>
+        </p:nvSpPr>
+        <p:spPr>
+          <a:xfrm>
+            <a:off x="612648" y="4617720"/>
+            <a:ext cx="5486400" cy="1600200"/>
           </a:xfrm>
           <a:prstGeom prst="roundRect">
             <a:avLst/>
@@ -8940,7 +8178,7 @@
           <a:lstStyle/>
           <a:p>
             <a:pPr algn="ctr">
-              <a:defRPr sz="919" b="1">
+              <a:defRPr sz="880" b="1">
                 <a:solidFill>
                   <a:srgbClr val="0D9488"/>
                 </a:solidFill>
@@ -8948,7 +8186,7 @@
               </a:defRPr>
             </a:pPr>
             <a:r>
-              <a:t>1. Operational Feasibility (Frontline Ready)</a:t>
+              <a:t>SUSTAINABLE B2G FINANCIAL MODEL &amp; OPERATIONAL VIABILITY</a:t>
             </a:r>
           </a:p>
           <a:p>
@@ -8956,7 +8194,7 @@
               <a:spcBef>
                 <a:spcPts val="150"/>
               </a:spcBef>
-              <a:defRPr sz="780">
+              <a:defRPr sz="710">
                 <a:solidFill>
                   <a:srgbClr val="1E293B"/>
                 </a:solidFill>
@@ -8964,7 +8202,7 @@
               </a:defRPr>
             </a:pPr>
             <a:r>
-              <a:t>• Replaces 8 duplicate paper registers with 50-second Marathi voice dictation.</a:t>
+              <a:t>• Operational Feasibility: Replaces 8 duplicate paper registers; works on existing smartphones.</a:t>
             </a:r>
           </a:p>
           <a:p>
@@ -8972,7 +8210,7 @@
               <a:spcBef>
                 <a:spcPts val="150"/>
               </a:spcBef>
-              <a:defRPr sz="780">
+              <a:defRPr sz="710">
                 <a:solidFill>
                   <a:srgbClr val="1E293B"/>
                 </a:solidFill>
@@ -8980,7 +8218,7 @@
               </a:defRPr>
             </a:pPr>
             <a:r>
-              <a:t>• Operates on existing government smartphones without purchasing specialized tablets.</a:t>
+              <a:t>• Sustainable Funding: Funded via State NHM PIP Innovation budget + ABDM DHIS incentives (₹500/bed/mo).</a:t>
             </a:r>
           </a:p>
           <a:p>
@@ -8988,7 +8226,7 @@
               <a:spcBef>
                 <a:spcPts val="150"/>
               </a:spcBef>
-              <a:defRPr sz="780">
+              <a:defRPr sz="710">
                 <a:solidFill>
                   <a:srgbClr val="1E293B"/>
                 </a:solidFill>
@@ -8996,62 +8234,7 @@
               </a:defRPr>
             </a:pPr>
             <a:r>
-              <a:t>• Designed for low-literacy ASHAs with audio cues, icons, and automated SMS.</a:t>
-            </a:r>
-          </a:p>
-        </p:txBody>
-      </p:sp>
-      <p:sp>
-        <p:nvSpPr>
-          <p:cNvPr id="17412" name="Rounded Rectangle 17411"/>
-          <p:cNvSpPr/>
-          <p:nvPr/>
-        </p:nvSpPr>
-        <p:spPr>
-          <a:xfrm>
-            <a:off x="612648" y="3063240"/>
-            <a:ext cx="4663440" cy="1508760"/>
-          </a:xfrm>
-          <a:prstGeom prst="roundRect">
-            <a:avLst/>
-          </a:prstGeom>
-          <a:solidFill>
-            <a:srgbClr val="EFF6FF"/>
-          </a:solidFill>
-          <a:ln w="15240">
-            <a:solidFill>
-              <a:srgbClr val="2563EB"/>
-            </a:solidFill>
-          </a:ln>
-        </p:spPr>
-        <p:style>
-          <a:lnRef idx="1">
-            <a:schemeClr val="accent1"/>
-          </a:lnRef>
-          <a:fillRef idx="3">
-            <a:schemeClr val="accent1"/>
-          </a:fillRef>
-          <a:effectRef idx="2">
-            <a:schemeClr val="accent1"/>
-          </a:effectRef>
-          <a:fontRef idx="minor">
-            <a:schemeClr val="lt1"/>
-          </a:fontRef>
-        </p:style>
-        <p:txBody>
-          <a:bodyPr rtlCol="0" anchor="ctr" wrap="square" lIns="109728" rIns="109728" tIns="73152"/>
-          <a:lstStyle/>
-          <a:p>
-            <a:pPr algn="ctr">
-              <a:defRPr sz="919" b="1">
-                <a:solidFill>
-                  <a:srgbClr val="2563EB"/>
-                </a:solidFill>
-                <a:latin typeface="Arial"/>
-              </a:defRPr>
-            </a:pPr>
-            <a:r>
-              <a:t>2. Technical Feasibility (Interoperable Rails)</a:t>
+              <a:t>• District Unit Economics: ~₹18 Lakh/year district operating cost vs ~₹35 Lakh/year state contract.</a:t>
             </a:r>
           </a:p>
           <a:p>
@@ -9059,7 +8242,7 @@
               <a:spcBef>
                 <a:spcPts val="150"/>
               </a:spcBef>
-              <a:defRPr sz="780">
+              <a:defRPr sz="710">
                 <a:solidFill>
                   <a:srgbClr val="1E293B"/>
                 </a:solidFill>
@@ -9067,157 +8250,22 @@
               </a:defRPr>
             </a:pPr>
             <a:r>
-              <a:t>• Integrates directly with live national APIs: ABDM (67 Cr ABHA IDs) &amp; Bhashini.</a:t>
-            </a:r>
-          </a:p>
-          <a:p>
-            <a:pPr>
-              <a:spcBef>
-                <a:spcPts val="150"/>
-              </a:spcBef>
-              <a:defRPr sz="780">
-                <a:solidFill>
-                  <a:srgbClr val="1E293B"/>
-                </a:solidFill>
-                <a:latin typeface="Arial"/>
-              </a:defRPr>
-            </a:pPr>
-            <a:r>
-              <a:t>• CRDT local replication guarantees zero data corruption during partial syncs.</a:t>
-            </a:r>
-          </a:p>
-          <a:p>
-            <a:pPr>
-              <a:spcBef>
-                <a:spcPts val="150"/>
-              </a:spcBef>
-              <a:defRPr sz="780">
-                <a:solidFill>
-                  <a:srgbClr val="1E293B"/>
-                </a:solidFill>
-                <a:latin typeface="Arial"/>
-              </a:defRPr>
-            </a:pPr>
-            <a:r>
-              <a:t>• Runs on proven open-source web and mobile architecture with MeitY cloud compliance.</a:t>
-            </a:r>
-          </a:p>
-        </p:txBody>
-      </p:sp>
-      <p:sp>
-        <p:nvSpPr>
-          <p:cNvPr id="17413" name="Rounded Rectangle 17412"/>
-          <p:cNvSpPr/>
-          <p:nvPr/>
-        </p:nvSpPr>
-        <p:spPr>
-          <a:xfrm>
-            <a:off x="612648" y="4681728"/>
-            <a:ext cx="4663440" cy="1508760"/>
-          </a:xfrm>
-          <a:prstGeom prst="roundRect">
-            <a:avLst/>
-          </a:prstGeom>
-          <a:solidFill>
-            <a:srgbClr val="F8FAFC"/>
-          </a:solidFill>
-          <a:ln w="15240">
-            <a:solidFill>
-              <a:srgbClr val="0F172A"/>
-            </a:solidFill>
-          </a:ln>
-        </p:spPr>
-        <p:style>
-          <a:lnRef idx="1">
-            <a:schemeClr val="accent1"/>
-          </a:lnRef>
-          <a:fillRef idx="3">
-            <a:schemeClr val="accent1"/>
-          </a:fillRef>
-          <a:effectRef idx="2">
-            <a:schemeClr val="accent1"/>
-          </a:effectRef>
-          <a:fontRef idx="minor">
-            <a:schemeClr val="lt1"/>
-          </a:fontRef>
-        </p:style>
-        <p:txBody>
-          <a:bodyPr rtlCol="0" anchor="ctr" wrap="square" lIns="109728" rIns="109728" tIns="73152"/>
-          <a:lstStyle/>
-          <a:p>
-            <a:pPr algn="ctr">
-              <a:defRPr sz="919" b="1">
-                <a:solidFill>
-                  <a:srgbClr val="0F172A"/>
-                </a:solidFill>
-                <a:latin typeface="Arial"/>
-              </a:defRPr>
-            </a:pPr>
-            <a:r>
-              <a:t>3. Financial Viability (B2G Unit Economics)</a:t>
-            </a:r>
-          </a:p>
-          <a:p>
-            <a:pPr>
-              <a:spcBef>
-                <a:spcPts val="150"/>
-              </a:spcBef>
-              <a:defRPr sz="780">
-                <a:solidFill>
-                  <a:srgbClr val="1E293B"/>
-                </a:solidFill>
-                <a:latin typeface="Arial"/>
-              </a:defRPr>
-            </a:pPr>
-            <a:r>
-              <a:t>• Funded via State NHM PIP Innovation budget + ABDM DHIS incentives (₹500/bed/mo).</a:t>
-            </a:r>
-          </a:p>
-          <a:p>
-            <a:pPr>
-              <a:spcBef>
-                <a:spcPts val="150"/>
-              </a:spcBef>
-              <a:defRPr sz="780">
-                <a:solidFill>
-                  <a:srgbClr val="1E293B"/>
-                </a:solidFill>
-                <a:latin typeface="Arial"/>
-              </a:defRPr>
-            </a:pPr>
-            <a:r>
-              <a:t>• District Operating Cost: ~₹18 Lakh/year vs. State Contract Value: ~₹35 Lakh/year.</a:t>
-            </a:r>
-          </a:p>
-          <a:p>
-            <a:pPr>
-              <a:spcBef>
-                <a:spcPts val="150"/>
-              </a:spcBef>
-              <a:defRPr sz="780">
-                <a:solidFill>
-                  <a:srgbClr val="1E293B"/>
-                </a:solidFill>
-                <a:latin typeface="Arial"/>
-              </a:defRPr>
-            </a:pPr>
-            <a:r>
-              <a:t>• 48.5% operating margin supports field engineers and frontline worker training.</a:t>
+              <a:t>• 48.5% operating margin directly funds village frontline worker training and field engineering support.</a:t>
             </a:r>
           </a:p>
         </p:txBody>
       </p:sp>
       <p:graphicFrame>
         <p:nvGraphicFramePr>
-          <p:cNvPr id="17414" name="Table 17413"/>
+          <p:cNvPr id="17413" name="Table 17412"/>
           <p:cNvGraphicFramePr>
             <a:graphicFrameLocks noGrp="1"/>
           </p:cNvGraphicFramePr>
           <p:nvPr/>
         </p:nvGraphicFramePr>
         <p:xfrm>
-          <a:off x="5440680" y="1444752"/>
-          <a:ext cx="6144768" cy="4754880"/>
+          <a:off x="6236208" y="1444752"/>
+          <a:ext cx="5349240" cy="4754880"/>
         </p:xfrm>
         <a:graphic>
           <a:graphicData uri="http://schemas.openxmlformats.org/drawingml/2006/table">
@@ -9226,9 +8274,9 @@
                 <a:tableStyleId>{5C22544A-7EE6-4342-B048-85BDC9FD1C3A}</a:tableStyleId>
               </a:tblPr>
               <a:tblGrid>
-                <a:gridCol w="1371600"/>
+                <a:gridCol w="1143000"/>
                 <a:gridCol w="2011680"/>
-                <a:gridCol w="2761488"/>
+                <a:gridCol w="2194560"/>
               </a:tblGrid>
               <a:tr h="365760">
                 <a:tc>
@@ -9237,7 +8285,7 @@
                     <a:lstStyle/>
                     <a:p>
                       <a:pPr>
-                        <a:defRPr sz="850" b="1">
+                        <a:defRPr sz="800" b="1">
                           <a:solidFill>
                             <a:srgbClr val="FFFFFF"/>
                           </a:solidFill>
@@ -9261,7 +8309,7 @@
                     <a:lstStyle/>
                     <a:p>
                       <a:pPr>
-                        <a:defRPr sz="850" b="1">
+                        <a:defRPr sz="800" b="1">
                           <a:solidFill>
                             <a:srgbClr val="FFFFFF"/>
                           </a:solidFill>
@@ -9285,7 +8333,7 @@
                     <a:lstStyle/>
                     <a:p>
                       <a:pPr>
-                        <a:defRPr sz="850" b="1">
+                        <a:defRPr sz="800" b="1">
                           <a:solidFill>
                             <a:srgbClr val="FFFFFF"/>
                           </a:solidFill>
@@ -9311,7 +8359,7 @@
                     <a:lstStyle/>
                     <a:p>
                       <a:pPr>
-                        <a:defRPr sz="780" b="1">
+                        <a:defRPr sz="740" b="1">
                           <a:solidFill>
                             <a:srgbClr val="2563EB"/>
                           </a:solidFill>
@@ -9335,7 +8383,7 @@
                     <a:lstStyle/>
                     <a:p>
                       <a:pPr>
-                        <a:defRPr sz="780">
+                        <a:defRPr sz="740">
                           <a:solidFill>
                             <a:srgbClr val="1E293B"/>
                           </a:solidFill>
@@ -9359,7 +8407,7 @@
                     <a:lstStyle/>
                     <a:p>
                       <a:pPr>
-                        <a:defRPr sz="780">
+                        <a:defRPr sz="740">
                           <a:solidFill>
                             <a:srgbClr val="1E293B"/>
                           </a:solidFill>
@@ -9385,7 +8433,7 @@
                     <a:lstStyle/>
                     <a:p>
                       <a:pPr>
-                        <a:defRPr sz="780" b="1">
+                        <a:defRPr sz="740" b="1">
                           <a:solidFill>
                             <a:srgbClr val="E11D48"/>
                           </a:solidFill>
@@ -9409,7 +8457,7 @@
                     <a:lstStyle/>
                     <a:p>
                       <a:pPr>
-                        <a:defRPr sz="780">
+                        <a:defRPr sz="740">
                           <a:solidFill>
                             <a:srgbClr val="1E293B"/>
                           </a:solidFill>
@@ -9433,7 +8481,7 @@
                     <a:lstStyle/>
                     <a:p>
                       <a:pPr>
-                        <a:defRPr sz="780">
+                        <a:defRPr sz="740">
                           <a:solidFill>
                             <a:srgbClr val="1E293B"/>
                           </a:solidFill>
@@ -9459,7 +8507,7 @@
                     <a:lstStyle/>
                     <a:p>
                       <a:pPr>
-                        <a:defRPr sz="780" b="1">
+                        <a:defRPr sz="740" b="1">
                           <a:solidFill>
                             <a:srgbClr val="E11D48"/>
                           </a:solidFill>
@@ -9483,7 +8531,7 @@
                     <a:lstStyle/>
                     <a:p>
                       <a:pPr>
-                        <a:defRPr sz="780">
+                        <a:defRPr sz="740">
                           <a:solidFill>
                             <a:srgbClr val="1E293B"/>
                           </a:solidFill>
@@ -9507,7 +8555,7 @@
                     <a:lstStyle/>
                     <a:p>
                       <a:pPr>
-                        <a:defRPr sz="780">
+                        <a:defRPr sz="740">
                           <a:solidFill>
                             <a:srgbClr val="1E293B"/>
                           </a:solidFill>
@@ -9533,7 +8581,7 @@
                     <a:lstStyle/>
                     <a:p>
                       <a:pPr>
-                        <a:defRPr sz="780" b="1">
+                        <a:defRPr sz="740" b="1">
                           <a:solidFill>
                             <a:srgbClr val="2563EB"/>
                           </a:solidFill>
@@ -9557,7 +8605,7 @@
                     <a:lstStyle/>
                     <a:p>
                       <a:pPr>
-                        <a:defRPr sz="780">
+                        <a:defRPr sz="740">
                           <a:solidFill>
                             <a:srgbClr val="1E293B"/>
                           </a:solidFill>
@@ -9581,7 +8629,7 @@
                     <a:lstStyle/>
                     <a:p>
                       <a:pPr>
-                        <a:defRPr sz="780">
+                        <a:defRPr sz="740">
                           <a:solidFill>
                             <a:srgbClr val="1E293B"/>
                           </a:solidFill>
@@ -10033,7 +9081,7 @@
         <p:spPr>
           <a:xfrm>
             <a:off x="612648" y="1444752"/>
-            <a:ext cx="2606040" cy="1280160"/>
+            <a:ext cx="2606040" cy="1051560"/>
           </a:xfrm>
           <a:prstGeom prst="roundRect">
             <a:avLst/>
@@ -10062,11 +9110,11 @@
           </a:fontRef>
         </p:style>
         <p:txBody>
-          <a:bodyPr rtlCol="0" anchor="ctr" wrap="square" lIns="109728" rIns="109728" tIns="73152"/>
+          <a:bodyPr rtlCol="0" anchor="ctr" wrap="square" tIns="54864"/>
           <a:lstStyle/>
           <a:p>
             <a:pPr algn="ctr">
-              <a:defRPr sz="1800" b="1">
+              <a:defRPr sz="1600" b="1">
                 <a:solidFill>
                   <a:srgbClr val="0D9488"/>
                 </a:solidFill>
@@ -10079,7 +9127,7 @@
           </a:p>
           <a:p>
             <a:pPr>
-              <a:defRPr sz="919" b="1">
+              <a:defRPr sz="850" b="1">
                 <a:solidFill>
                   <a:srgbClr val="0F172A"/>
                 </a:solidFill>
@@ -10093,9 +9141,9 @@
           <a:p>
             <a:pPr>
               <a:spcBef>
-                <a:spcPts val="200"/>
+                <a:spcPts val="100"/>
               </a:spcBef>
-              <a:defRPr sz="750">
+              <a:defRPr sz="700">
                 <a:solidFill>
                   <a:srgbClr val="1E293B"/>
                 </a:solidFill>
@@ -10103,7 +9151,7 @@
               </a:defRPr>
             </a:pPr>
             <a:r>
-              <a:t>Slashed from 48.2% baseline via closed-loop tracking &amp; active navigation.</a:t>
+              <a:t>Slashed from 48.2% baseline via closed-loop tracking.</a:t>
             </a:r>
           </a:p>
         </p:txBody>
@@ -10117,7 +9165,7 @@
         <p:spPr>
           <a:xfrm>
             <a:off x="3401568" y="1444752"/>
-            <a:ext cx="2606040" cy="1280160"/>
+            <a:ext cx="2606040" cy="1051560"/>
           </a:xfrm>
           <a:prstGeom prst="roundRect">
             <a:avLst/>
@@ -10146,11 +9194,11 @@
           </a:fontRef>
         </p:style>
         <p:txBody>
-          <a:bodyPr rtlCol="0" anchor="ctr" wrap="square" lIns="109728" rIns="109728" tIns="73152"/>
+          <a:bodyPr rtlCol="0" anchor="ctr" wrap="square" tIns="54864"/>
           <a:lstStyle/>
           <a:p>
             <a:pPr algn="ctr">
-              <a:defRPr sz="1800" b="1">
+              <a:defRPr sz="1600" b="1">
                 <a:solidFill>
                   <a:srgbClr val="2563EB"/>
                 </a:solidFill>
@@ -10163,7 +9211,7 @@
           </a:p>
           <a:p>
             <a:pPr>
-              <a:defRPr sz="919" b="1">
+              <a:defRPr sz="850" b="1">
                 <a:solidFill>
                   <a:srgbClr val="0F172A"/>
                 </a:solidFill>
@@ -10171,15 +9219,15 @@
               </a:defRPr>
             </a:pPr>
             <a:r>
-              <a:t>OOPE Travel Reduction</a:t>
+              <a:t>OOPE Travel Cut</a:t>
             </a:r>
           </a:p>
           <a:p>
             <a:pPr>
               <a:spcBef>
-                <a:spcPts val="200"/>
+                <a:spcPts val="100"/>
               </a:spcBef>
-              <a:defRPr sz="750">
+              <a:defRPr sz="700">
                 <a:solidFill>
                   <a:srgbClr val="1E293B"/>
                 </a:solidFill>
@@ -10187,7 +9235,7 @@
               </a:defRPr>
             </a:pPr>
             <a:r>
-              <a:t>Saves rural families from debt traps via Coordinated One-Trip Care Bundles.</a:t>
+              <a:t>Saves families from debt traps via Coordinated One-Trip.</a:t>
             </a:r>
           </a:p>
         </p:txBody>
@@ -10201,7 +9249,7 @@
         <p:spPr>
           <a:xfrm>
             <a:off x="6190488" y="1444752"/>
-            <a:ext cx="2606040" cy="1280160"/>
+            <a:ext cx="2606040" cy="1051560"/>
           </a:xfrm>
           <a:prstGeom prst="roundRect">
             <a:avLst/>
@@ -10230,11 +9278,11 @@
           </a:fontRef>
         </p:style>
         <p:txBody>
-          <a:bodyPr rtlCol="0" anchor="ctr" wrap="square" lIns="109728" rIns="109728" tIns="73152"/>
+          <a:bodyPr rtlCol="0" anchor="ctr" wrap="square" tIns="54864"/>
           <a:lstStyle/>
           <a:p>
             <a:pPr algn="ctr">
-              <a:defRPr sz="1800" b="1">
+              <a:defRPr sz="1600" b="1">
                 <a:solidFill>
                   <a:srgbClr val="0F172A"/>
                 </a:solidFill>
@@ -10247,7 +9295,7 @@
           </a:p>
           <a:p>
             <a:pPr>
-              <a:defRPr sz="919" b="1">
+              <a:defRPr sz="850" b="1">
                 <a:solidFill>
                   <a:srgbClr val="0F172A"/>
                 </a:solidFill>
@@ -10261,9 +9309,9 @@
           <a:p>
             <a:pPr>
               <a:spcBef>
-                <a:spcPts val="200"/>
+                <a:spcPts val="100"/>
               </a:spcBef>
-              <a:defRPr sz="750">
+              <a:defRPr sz="700">
                 <a:solidFill>
                   <a:srgbClr val="1E293B"/>
                 </a:solidFill>
@@ -10271,7 +9319,7 @@
               </a:defRPr>
             </a:pPr>
             <a:r>
-              <a:t>Fast-track casualty triage bypasses 3.5-hour general OPD queues.</a:t>
+              <a:t>Fast-track casualty triage bypasses 3.5h general queues.</a:t>
             </a:r>
           </a:p>
         </p:txBody>
@@ -10285,7 +9333,7 @@
         <p:spPr>
           <a:xfrm>
             <a:off x="8979408" y="1444752"/>
-            <a:ext cx="2606040" cy="1280160"/>
+            <a:ext cx="2606040" cy="1051560"/>
           </a:xfrm>
           <a:prstGeom prst="roundRect">
             <a:avLst/>
@@ -10314,11 +9362,11 @@
           </a:fontRef>
         </p:style>
         <p:txBody>
-          <a:bodyPr rtlCol="0" anchor="ctr" wrap="square" lIns="109728" rIns="109728" tIns="73152"/>
+          <a:bodyPr rtlCol="0" anchor="ctr" wrap="square" tIns="54864"/>
           <a:lstStyle/>
           <a:p>
             <a:pPr algn="ctr">
-              <a:defRPr sz="1800" b="1">
+              <a:defRPr sz="1600" b="1">
                 <a:solidFill>
                   <a:srgbClr val="10B981"/>
                 </a:solidFill>
@@ -10331,7 +9379,7 @@
           </a:p>
           <a:p>
             <a:pPr>
-              <a:defRPr sz="919" b="1">
+              <a:defRPr sz="850" b="1">
                 <a:solidFill>
                   <a:srgbClr val="0F172A"/>
                 </a:solidFill>
@@ -10345,9 +9393,9 @@
           <a:p>
             <a:pPr>
               <a:spcBef>
-                <a:spcPts val="200"/>
+                <a:spcPts val="100"/>
               </a:spcBef>
-              <a:defRPr sz="750">
+              <a:defRPr sz="700">
                 <a:solidFill>
                   <a:srgbClr val="1E293B"/>
                 </a:solidFill>
@@ -10355,21 +9403,45 @@
               </a:defRPr>
             </a:pPr>
             <a:r>
-              <a:t>Automated counter-referral tasks sent to village ASHAs on patient discharge.</a:t>
-            </a:r>
-          </a:p>
-        </p:txBody>
-      </p:sp>
-      <p:sp>
-        <p:nvSpPr>
-          <p:cNvPr id="17415" name="Rounded Rectangle 17414"/>
+              <a:t>Automated counter-referral tasks sent to village ASHAs.</a:t>
+            </a:r>
+          </a:p>
+        </p:txBody>
+      </p:sp>
+      <p:pic>
+        <p:nvPicPr>
+          <p:cNvPr id="17415" name="Picture 17414" descr="impact_pillars_infographic.jpg"/>
+          <p:cNvPicPr>
+            <a:picLocks noChangeAspect="1"/>
+          </p:cNvPicPr>
+          <p:nvPr/>
+        </p:nvPicPr>
+        <p:blipFill>
+          <a:blip r:embed="rId4"/>
+          <a:stretch>
+            <a:fillRect/>
+          </a:stretch>
+        </p:blipFill>
+        <p:spPr>
+          <a:xfrm>
+            <a:off x="612648" y="2633472"/>
+            <a:ext cx="5852160" cy="3291840"/>
+          </a:xfrm>
+          <a:prstGeom prst="rect">
+            <a:avLst/>
+          </a:prstGeom>
+        </p:spPr>
+      </p:pic>
+      <p:sp>
+        <p:nvSpPr>
+          <p:cNvPr id="17416" name="Rounded Rectangle 17415"/>
           <p:cNvSpPr/>
           <p:nvPr/>
         </p:nvSpPr>
         <p:spPr>
           <a:xfrm>
-            <a:off x="612648" y="2852928"/>
-            <a:ext cx="5349240" cy="1645920"/>
+            <a:off x="6693408" y="2633472"/>
+            <a:ext cx="4892040" cy="777240"/>
           </a:xfrm>
           <a:prstGeom prst="roundRect">
             <a:avLst/>
@@ -10377,7 +9449,7 @@
           <a:solidFill>
             <a:srgbClr val="FEF2F2"/>
           </a:solidFill>
-          <a:ln w="15240">
+          <a:ln w="12700">
             <a:solidFill>
               <a:srgbClr val="E11D48"/>
             </a:solidFill>
@@ -10398,11 +9470,11 @@
           </a:fontRef>
         </p:style>
         <p:txBody>
-          <a:bodyPr rtlCol="0" anchor="ctr" wrap="square" lIns="109728" rIns="109728" tIns="73152"/>
+          <a:bodyPr rtlCol="0" anchor="ctr" wrap="square"/>
           <a:lstStyle/>
           <a:p>
             <a:pPr algn="ctr">
-              <a:defRPr sz="919" b="1">
+              <a:defRPr sz="800" b="1">
                 <a:solidFill>
                   <a:srgbClr val="E11D48"/>
                 </a:solidFill>
@@ -10418,7 +9490,7 @@
               <a:spcBef>
                 <a:spcPts val="150"/>
               </a:spcBef>
-              <a:defRPr sz="780">
+              <a:defRPr sz="680">
                 <a:solidFill>
                   <a:srgbClr val="1E293B"/>
                 </a:solidFill>
@@ -10426,53 +9498,21 @@
               </a:defRPr>
             </a:pPr>
             <a:r>
-              <a:t>• Prevents maternal mortality (PPH, eclampsia) &amp; cardiac deaths in tribal blocks (Melghat, Nandurbar).</a:t>
-            </a:r>
-          </a:p>
-          <a:p>
-            <a:pPr>
-              <a:spcBef>
-                <a:spcPts val="150"/>
-              </a:spcBef>
-              <a:defRPr sz="780">
-                <a:solidFill>
-                  <a:srgbClr val="1E293B"/>
-                </a:solidFill>
-                <a:latin typeface="Arial"/>
-              </a:defRPr>
-            </a:pPr>
-            <a:r>
-              <a:t>• Eliminates fear and confusion for illiterate citizens through vernacular voice guidance.</a:t>
-            </a:r>
-          </a:p>
-          <a:p>
-            <a:pPr>
-              <a:spcBef>
-                <a:spcPts val="150"/>
-              </a:spcBef>
-              <a:defRPr sz="780">
-                <a:solidFill>
-                  <a:srgbClr val="1E293B"/>
-                </a:solidFill>
-                <a:latin typeface="Arial"/>
-              </a:defRPr>
-            </a:pPr>
-            <a:r>
-              <a:t>• Empowers frontline women (ASHAs) as digital healthcare leaders in their community.</a:t>
-            </a:r>
-          </a:p>
-        </p:txBody>
-      </p:sp>
-      <p:sp>
-        <p:nvSpPr>
-          <p:cNvPr id="17416" name="Rounded Rectangle 17415"/>
+              <a:t>Prevents maternal deaths (PPH, eclampsia) &amp; cardiac crises in tribal blocks (Melghat, Nandurbar); vernacular voice guides illiterate families; empowers ASHAs.</a:t>
+            </a:r>
+          </a:p>
+        </p:txBody>
+      </p:sp>
+      <p:sp>
+        <p:nvSpPr>
+          <p:cNvPr id="17417" name="Rounded Rectangle 17416"/>
           <p:cNvSpPr/>
           <p:nvPr/>
         </p:nvSpPr>
         <p:spPr>
           <a:xfrm>
-            <a:off x="6236208" y="2852928"/>
-            <a:ext cx="5349240" cy="1645920"/>
+            <a:off x="6693408" y="3474720"/>
+            <a:ext cx="4892040" cy="777240"/>
           </a:xfrm>
           <a:prstGeom prst="roundRect">
             <a:avLst/>
@@ -10480,7 +9520,7 @@
           <a:solidFill>
             <a:srgbClr val="EFF6FF"/>
           </a:solidFill>
-          <a:ln w="15240">
+          <a:ln w="12700">
             <a:solidFill>
               <a:srgbClr val="2563EB"/>
             </a:solidFill>
@@ -10501,11 +9541,11 @@
           </a:fontRef>
         </p:style>
         <p:txBody>
-          <a:bodyPr rtlCol="0" anchor="ctr" wrap="square" lIns="109728" rIns="109728" tIns="73152"/>
+          <a:bodyPr rtlCol="0" anchor="ctr" wrap="square"/>
           <a:lstStyle/>
           <a:p>
             <a:pPr algn="ctr">
-              <a:defRPr sz="919" b="1">
+              <a:defRPr sz="800" b="1">
                 <a:solidFill>
                   <a:srgbClr val="2563EB"/>
                 </a:solidFill>
@@ -10521,7 +9561,7 @@
               <a:spcBef>
                 <a:spcPts val="150"/>
               </a:spcBef>
-              <a:defRPr sz="780">
+              <a:defRPr sz="680">
                 <a:solidFill>
                   <a:srgbClr val="1E293B"/>
                 </a:solidFill>
@@ -10529,53 +9569,21 @@
               </a:defRPr>
             </a:pPr>
             <a:r>
-              <a:t>• Health expenses push 55 million Indians into poverty annually; platform cuts private jeep &amp; repeat test costs.</a:t>
-            </a:r>
-          </a:p>
-          <a:p>
-            <a:pPr>
-              <a:spcBef>
-                <a:spcPts val="150"/>
-              </a:spcBef>
-              <a:defRPr sz="780">
-                <a:solidFill>
-                  <a:srgbClr val="1E293B"/>
-                </a:solidFill>
-                <a:latin typeface="Arial"/>
-              </a:defRPr>
-            </a:pPr>
-            <a:r>
-              <a:t>• Reduces tertiary hospital over-utilization by triaging treatable cases at primary PHC/CHC level.</a:t>
-            </a:r>
-          </a:p>
-          <a:p>
-            <a:pPr>
-              <a:spcBef>
-                <a:spcPts val="150"/>
-              </a:spcBef>
-              <a:defRPr sz="780">
-                <a:solidFill>
-                  <a:srgbClr val="1E293B"/>
-                </a:solidFill>
-                <a:latin typeface="Arial"/>
-              </a:defRPr>
-            </a:pPr>
-            <a:r>
-              <a:t>• Unlocks ABDM DHIS federal cash incentives (₹500/bed/mo) for participating state hospitals.</a:t>
-            </a:r>
-          </a:p>
-        </p:txBody>
-      </p:sp>
-      <p:sp>
-        <p:nvSpPr>
-          <p:cNvPr id="17417" name="Rounded Rectangle 17416"/>
+              <a:t>Cuts private transport and redundant diagnostic fees that push 55M into poverty yearly; unlocks ABDM DHIS hospital cash incentives (₹500/bed/mo).</a:t>
+            </a:r>
+          </a:p>
+        </p:txBody>
+      </p:sp>
+      <p:sp>
+        <p:nvSpPr>
+          <p:cNvPr id="17418" name="Rounded Rectangle 17417"/>
           <p:cNvSpPr/>
           <p:nvPr/>
         </p:nvSpPr>
         <p:spPr>
           <a:xfrm>
-            <a:off x="612648" y="4608576"/>
-            <a:ext cx="5349240" cy="1645920"/>
+            <a:off x="6693408" y="4315968"/>
+            <a:ext cx="4892040" cy="777240"/>
           </a:xfrm>
           <a:prstGeom prst="roundRect">
             <a:avLst/>
@@ -10583,7 +9591,7 @@
           <a:solidFill>
             <a:srgbClr val="ECFDF5"/>
           </a:solidFill>
-          <a:ln w="15240">
+          <a:ln w="12700">
             <a:solidFill>
               <a:srgbClr val="10B981"/>
             </a:solidFill>
@@ -10604,11 +9612,11 @@
           </a:fontRef>
         </p:style>
         <p:txBody>
-          <a:bodyPr rtlCol="0" anchor="ctr" wrap="square" lIns="109728" rIns="109728" tIns="73152"/>
+          <a:bodyPr rtlCol="0" anchor="ctr" wrap="square"/>
           <a:lstStyle/>
           <a:p>
             <a:pPr algn="ctr">
-              <a:defRPr sz="919" b="1">
+              <a:defRPr sz="800" b="1">
                 <a:solidFill>
                   <a:srgbClr val="10B981"/>
                 </a:solidFill>
@@ -10624,7 +9632,7 @@
               <a:spcBef>
                 <a:spcPts val="150"/>
               </a:spcBef>
-              <a:defRPr sz="780">
+              <a:defRPr sz="680">
                 <a:solidFill>
                   <a:srgbClr val="1E293B"/>
                 </a:solidFill>
@@ -10632,53 +9640,21 @@
               </a:defRPr>
             </a:pPr>
             <a:r>
-              <a:t>• Replaces millions of physical registers and paper referral slips with digital records.</a:t>
-            </a:r>
-          </a:p>
-          <a:p>
-            <a:pPr>
-              <a:spcBef>
-                <a:spcPts val="150"/>
-              </a:spcBef>
-              <a:defRPr sz="780">
-                <a:solidFill>
-                  <a:srgbClr val="1E293B"/>
-                </a:solidFill>
-                <a:latin typeface="Arial"/>
-              </a:defRPr>
-            </a:pPr>
-            <a:r>
-              <a:t>• Significantly cuts vehicular emissions and fuel consumption from repeated, failed hospital trips.</a:t>
-            </a:r>
-          </a:p>
-          <a:p>
-            <a:pPr>
-              <a:spcBef>
-                <a:spcPts val="150"/>
-              </a:spcBef>
-              <a:defRPr sz="780">
-                <a:solidFill>
-                  <a:srgbClr val="1E293B"/>
-                </a:solidFill>
-                <a:latin typeface="Arial"/>
-              </a:defRPr>
-            </a:pPr>
-            <a:r>
-              <a:t>• Eco-friendly server architecture optimized for low-power edge execution.</a:t>
-            </a:r>
-          </a:p>
-        </p:txBody>
-      </p:sp>
-      <p:sp>
-        <p:nvSpPr>
-          <p:cNvPr id="17418" name="Rounded Rectangle 17417"/>
+              <a:t>Replaces millions of paper registers with digital health records; slashes transit vehicular emissions from repeated, failed hospital trips.</a:t>
+            </a:r>
+          </a:p>
+        </p:txBody>
+      </p:sp>
+      <p:sp>
+        <p:nvSpPr>
+          <p:cNvPr id="17419" name="Rounded Rectangle 17418"/>
           <p:cNvSpPr/>
           <p:nvPr/>
         </p:nvSpPr>
         <p:spPr>
           <a:xfrm>
-            <a:off x="6236208" y="4608576"/>
-            <a:ext cx="5349240" cy="1645920"/>
+            <a:off x="6693408" y="5157216"/>
+            <a:ext cx="4892040" cy="777240"/>
           </a:xfrm>
           <a:prstGeom prst="roundRect">
             <a:avLst/>
@@ -10686,7 +9662,7 @@
           <a:solidFill>
             <a:srgbClr val="F8FAFC"/>
           </a:solidFill>
-          <a:ln w="15240">
+          <a:ln w="12700">
             <a:solidFill>
               <a:srgbClr val="0F172A"/>
             </a:solidFill>
@@ -10707,11 +9683,11 @@
           </a:fontRef>
         </p:style>
         <p:txBody>
-          <a:bodyPr rtlCol="0" anchor="ctr" wrap="square" lIns="109728" rIns="109728" tIns="73152"/>
+          <a:bodyPr rtlCol="0" anchor="ctr" wrap="square"/>
           <a:lstStyle/>
           <a:p>
             <a:pPr algn="ctr">
-              <a:defRPr sz="919" b="1">
+              <a:defRPr sz="800" b="1">
                 <a:solidFill>
                   <a:srgbClr val="0F172A"/>
                 </a:solidFill>
@@ -10727,7 +9703,7 @@
               <a:spcBef>
                 <a:spcPts val="150"/>
               </a:spcBef>
-              <a:defRPr sz="780">
+              <a:defRPr sz="680">
                 <a:solidFill>
                   <a:srgbClr val="1E293B"/>
                 </a:solidFill>
@@ -10735,39 +9711,7 @@
               </a:defRPr>
             </a:pPr>
             <a:r>
-              <a:t>• Live District Health Officer (DHO) bottleneck heatmaps surface specialist shortages &amp; equipment outages.</a:t>
-            </a:r>
-          </a:p>
-          <a:p>
-            <a:pPr>
-              <a:spcBef>
-                <a:spcPts val="150"/>
-              </a:spcBef>
-              <a:defRPr sz="780">
-                <a:solidFill>
-                  <a:srgbClr val="1E293B"/>
-                </a:solidFill>
-                <a:latin typeface="Arial"/>
-              </a:defRPr>
-            </a:pPr>
-            <a:r>
-              <a:t>• Replaces delayed 45-day HMIS aggregate reports with actionable operational telemetry.</a:t>
-            </a:r>
-          </a:p>
-          <a:p>
-            <a:pPr>
-              <a:spcBef>
-                <a:spcPts val="150"/>
-              </a:spcBef>
-              <a:defRPr sz="780">
-                <a:solidFill>
-                  <a:srgbClr val="1E293B"/>
-                </a:solidFill>
-                <a:latin typeface="Arial"/>
-              </a:defRPr>
-            </a:pPr>
-            <a:r>
-              <a:t>• Provides accountability across secondary facilities for referral turnaround and bed readiness.</a:t>
+              <a:t>Live District Health Officer (DHO) bottleneck heatmaps surface specialist shortages &amp; equipment outages; replaces delayed 45-day HMIS reports.</a:t>
             </a:r>
           </a:p>
         </p:txBody>
@@ -11202,7 +10146,7 @@
         </p:nvGraphicFramePr>
         <p:xfrm>
           <a:off x="612648" y="1444752"/>
-          <a:ext cx="10972800" cy="2331720"/>
+          <a:ext cx="10972800" cy="2121408"/>
         </p:xfrm>
         <a:graphic>
           <a:graphicData uri="http://schemas.openxmlformats.org/drawingml/2006/table">
@@ -11218,14 +10162,14 @@
                 <a:gridCol w="1737360"/>
                 <a:gridCol w="1737360"/>
               </a:tblGrid>
-              <a:tr h="320040">
+              <a:tr h="292608">
                 <a:tc>
                   <a:txBody>
                     <a:bodyPr/>
                     <a:lstStyle/>
                     <a:p>
                       <a:pPr>
-                        <a:defRPr sz="800" b="1">
+                        <a:defRPr sz="780" b="1">
                           <a:solidFill>
                             <a:srgbClr val="FFFFFF"/>
                           </a:solidFill>
@@ -11249,7 +10193,7 @@
                     <a:lstStyle/>
                     <a:p>
                       <a:pPr>
-                        <a:defRPr sz="800" b="1">
+                        <a:defRPr sz="780" b="1">
                           <a:solidFill>
                             <a:srgbClr val="FFFFFF"/>
                           </a:solidFill>
@@ -11273,7 +10217,7 @@
                     <a:lstStyle/>
                     <a:p>
                       <a:pPr>
-                        <a:defRPr sz="800" b="1">
+                        <a:defRPr sz="780" b="1">
                           <a:solidFill>
                             <a:srgbClr val="FFFFFF"/>
                           </a:solidFill>
@@ -11297,7 +10241,7 @@
                     <a:lstStyle/>
                     <a:p>
                       <a:pPr>
-                        <a:defRPr sz="800" b="1">
+                        <a:defRPr sz="780" b="1">
                           <a:solidFill>
                             <a:srgbClr val="FFFFFF"/>
                           </a:solidFill>
@@ -11321,7 +10265,7 @@
                     <a:lstStyle/>
                     <a:p>
                       <a:pPr>
-                        <a:defRPr sz="800" b="1">
+                        <a:defRPr sz="780" b="1">
                           <a:solidFill>
                             <a:srgbClr val="FFFFFF"/>
                           </a:solidFill>
@@ -11345,7 +10289,7 @@
                     <a:lstStyle/>
                     <a:p>
                       <a:pPr>
-                        <a:defRPr sz="800" b="1">
+                        <a:defRPr sz="780" b="1">
                           <a:solidFill>
                             <a:srgbClr val="FFFFFF"/>
                           </a:solidFill>
@@ -11364,14 +10308,14 @@
                   </a:tcPr>
                 </a:tc>
               </a:tr>
-              <a:tr h="402336">
+              <a:tr h="365760">
                 <a:tc>
                   <a:txBody>
                     <a:bodyPr/>
                     <a:lstStyle/>
                     <a:p>
                       <a:pPr>
-                        <a:defRPr sz="750" b="1">
+                        <a:defRPr sz="720" b="1">
                           <a:solidFill>
                             <a:srgbClr val="0F172A"/>
                           </a:solidFill>
@@ -11395,7 +10339,7 @@
                     <a:lstStyle/>
                     <a:p>
                       <a:pPr>
-                        <a:defRPr sz="750">
+                        <a:defRPr sz="720">
                           <a:solidFill>
                             <a:srgbClr val="E11D48"/>
                           </a:solidFill>
@@ -11419,7 +10363,7 @@
                     <a:lstStyle/>
                     <a:p>
                       <a:pPr>
-                        <a:defRPr sz="750">
+                        <a:defRPr sz="720">
                           <a:solidFill>
                             <a:srgbClr val="E11D48"/>
                           </a:solidFill>
@@ -11443,7 +10387,7 @@
                     <a:lstStyle/>
                     <a:p>
                       <a:pPr>
-                        <a:defRPr sz="750">
+                        <a:defRPr sz="720">
                           <a:solidFill>
                             <a:srgbClr val="D97706"/>
                           </a:solidFill>
@@ -11467,7 +10411,7 @@
                     <a:lstStyle/>
                     <a:p>
                       <a:pPr>
-                        <a:defRPr sz="750">
+                        <a:defRPr sz="720">
                           <a:solidFill>
                             <a:srgbClr val="E11D48"/>
                           </a:solidFill>
@@ -11491,7 +10435,7 @@
                     <a:lstStyle/>
                     <a:p>
                       <a:pPr>
-                        <a:defRPr sz="750" b="1">
+                        <a:defRPr sz="720" b="1">
                           <a:solidFill>
                             <a:srgbClr val="0D9488"/>
                           </a:solidFill>
@@ -11510,14 +10454,14 @@
                   </a:tcPr>
                 </a:tc>
               </a:tr>
-              <a:tr h="402336">
+              <a:tr h="365760">
                 <a:tc>
                   <a:txBody>
                     <a:bodyPr/>
                     <a:lstStyle/>
                     <a:p>
                       <a:pPr>
-                        <a:defRPr sz="750" b="1">
+                        <a:defRPr sz="720" b="1">
                           <a:solidFill>
                             <a:srgbClr val="0F172A"/>
                           </a:solidFill>
@@ -11541,7 +10485,7 @@
                     <a:lstStyle/>
                     <a:p>
                       <a:pPr>
-                        <a:defRPr sz="750">
+                        <a:defRPr sz="720">
                           <a:solidFill>
                             <a:srgbClr val="E11D48"/>
                           </a:solidFill>
@@ -11565,7 +10509,7 @@
                     <a:lstStyle/>
                     <a:p>
                       <a:pPr>
-                        <a:defRPr sz="750">
+                        <a:defRPr sz="720">
                           <a:solidFill>
                             <a:srgbClr val="E11D48"/>
                           </a:solidFill>
@@ -11589,7 +10533,7 @@
                     <a:lstStyle/>
                     <a:p>
                       <a:pPr>
-                        <a:defRPr sz="750">
+                        <a:defRPr sz="720">
                           <a:solidFill>
                             <a:srgbClr val="1E293B"/>
                           </a:solidFill>
@@ -11613,7 +10557,7 @@
                     <a:lstStyle/>
                     <a:p>
                       <a:pPr>
-                        <a:defRPr sz="750">
+                        <a:defRPr sz="720">
                           <a:solidFill>
                             <a:srgbClr val="D97706"/>
                           </a:solidFill>
@@ -11637,7 +10581,7 @@
                     <a:lstStyle/>
                     <a:p>
                       <a:pPr>
-                        <a:defRPr sz="750" b="1">
+                        <a:defRPr sz="720" b="1">
                           <a:solidFill>
                             <a:srgbClr val="0D9488"/>
                           </a:solidFill>
@@ -11656,14 +10600,14 @@
                   </a:tcPr>
                 </a:tc>
               </a:tr>
-              <a:tr h="402336">
+              <a:tr h="365760">
                 <a:tc>
                   <a:txBody>
                     <a:bodyPr/>
                     <a:lstStyle/>
                     <a:p>
                       <a:pPr>
-                        <a:defRPr sz="750" b="1">
+                        <a:defRPr sz="720" b="1">
                           <a:solidFill>
                             <a:srgbClr val="0F172A"/>
                           </a:solidFill>
@@ -11687,7 +10631,7 @@
                     <a:lstStyle/>
                     <a:p>
                       <a:pPr>
-                        <a:defRPr sz="750">
+                        <a:defRPr sz="720">
                           <a:solidFill>
                             <a:srgbClr val="E11D48"/>
                           </a:solidFill>
@@ -11711,7 +10655,7 @@
                     <a:lstStyle/>
                     <a:p>
                       <a:pPr>
-                        <a:defRPr sz="750">
+                        <a:defRPr sz="720">
                           <a:solidFill>
                             <a:srgbClr val="E11D48"/>
                           </a:solidFill>
@@ -11735,7 +10679,7 @@
                     <a:lstStyle/>
                     <a:p>
                       <a:pPr>
-                        <a:defRPr sz="750">
+                        <a:defRPr sz="720">
                           <a:solidFill>
                             <a:srgbClr val="E11D48"/>
                           </a:solidFill>
@@ -11759,7 +10703,7 @@
                     <a:lstStyle/>
                     <a:p>
                       <a:pPr>
-                        <a:defRPr sz="750">
+                        <a:defRPr sz="720">
                           <a:solidFill>
                             <a:srgbClr val="E11D48"/>
                           </a:solidFill>
@@ -11783,7 +10727,7 @@
                     <a:lstStyle/>
                     <a:p>
                       <a:pPr>
-                        <a:defRPr sz="750" b="1">
+                        <a:defRPr sz="720" b="1">
                           <a:solidFill>
                             <a:srgbClr val="0D9488"/>
                           </a:solidFill>
@@ -11802,14 +10746,14 @@
                   </a:tcPr>
                 </a:tc>
               </a:tr>
-              <a:tr h="402336">
+              <a:tr h="365760">
                 <a:tc>
                   <a:txBody>
                     <a:bodyPr/>
                     <a:lstStyle/>
                     <a:p>
                       <a:pPr>
-                        <a:defRPr sz="750" b="1">
+                        <a:defRPr sz="720" b="1">
                           <a:solidFill>
                             <a:srgbClr val="0F172A"/>
                           </a:solidFill>
@@ -11833,7 +10777,7 @@
                     <a:lstStyle/>
                     <a:p>
                       <a:pPr>
-                        <a:defRPr sz="750">
+                        <a:defRPr sz="720">
                           <a:solidFill>
                             <a:srgbClr val="E11D48"/>
                           </a:solidFill>
@@ -11857,7 +10801,7 @@
                     <a:lstStyle/>
                     <a:p>
                       <a:pPr>
-                        <a:defRPr sz="750">
+                        <a:defRPr sz="720">
                           <a:solidFill>
                             <a:srgbClr val="E11D48"/>
                           </a:solidFill>
@@ -11881,7 +10825,7 @@
                     <a:lstStyle/>
                     <a:p>
                       <a:pPr>
-                        <a:defRPr sz="750">
+                        <a:defRPr sz="720">
                           <a:solidFill>
                             <a:srgbClr val="E11D48"/>
                           </a:solidFill>
@@ -11905,7 +10849,7 @@
                     <a:lstStyle/>
                     <a:p>
                       <a:pPr>
-                        <a:defRPr sz="750">
+                        <a:defRPr sz="720">
                           <a:solidFill>
                             <a:srgbClr val="D97706"/>
                           </a:solidFill>
@@ -11929,7 +10873,7 @@
                     <a:lstStyle/>
                     <a:p>
                       <a:pPr>
-                        <a:defRPr sz="750" b="1">
+                        <a:defRPr sz="720" b="1">
                           <a:solidFill>
                             <a:srgbClr val="0D9488"/>
                           </a:solidFill>
@@ -11948,14 +10892,14 @@
                   </a:tcPr>
                 </a:tc>
               </a:tr>
-              <a:tr h="402336">
+              <a:tr h="365760">
                 <a:tc>
                   <a:txBody>
                     <a:bodyPr/>
                     <a:lstStyle/>
                     <a:p>
                       <a:pPr>
-                        <a:defRPr sz="750" b="1">
+                        <a:defRPr sz="720" b="1">
                           <a:solidFill>
                             <a:srgbClr val="0F172A"/>
                           </a:solidFill>
@@ -11979,7 +10923,7 @@
                     <a:lstStyle/>
                     <a:p>
                       <a:pPr>
-                        <a:defRPr sz="750">
+                        <a:defRPr sz="720">
                           <a:solidFill>
                             <a:srgbClr val="E11D48"/>
                           </a:solidFill>
@@ -12003,7 +10947,7 @@
                     <a:lstStyle/>
                     <a:p>
                       <a:pPr>
-                        <a:defRPr sz="750">
+                        <a:defRPr sz="720">
                           <a:solidFill>
                             <a:srgbClr val="E11D48"/>
                           </a:solidFill>
@@ -12027,7 +10971,7 @@
                     <a:lstStyle/>
                     <a:p>
                       <a:pPr>
-                        <a:defRPr sz="750">
+                        <a:defRPr sz="720">
                           <a:solidFill>
                             <a:srgbClr val="E11D48"/>
                           </a:solidFill>
@@ -12051,7 +10995,7 @@
                     <a:lstStyle/>
                     <a:p>
                       <a:pPr>
-                        <a:defRPr sz="750">
+                        <a:defRPr sz="720">
                           <a:solidFill>
                             <a:srgbClr val="E11D48"/>
                           </a:solidFill>
@@ -12075,7 +11019,7 @@
                     <a:lstStyle/>
                     <a:p>
                       <a:pPr>
-                        <a:defRPr sz="750" b="1">
+                        <a:defRPr sz="720" b="1">
                           <a:solidFill>
                             <a:srgbClr val="0D9488"/>
                           </a:solidFill>
@@ -12098,16 +11042,40 @@
           </a:graphicData>
         </a:graphic>
       </p:graphicFrame>
-      <p:sp>
-        <p:nvSpPr>
-          <p:cNvPr id="17412" name="Rounded Rectangle 17411"/>
+      <p:pic>
+        <p:nvPicPr>
+          <p:cNvPr id="17412" name="Picture 17411" descr="research_evidence_infographic.jpg"/>
+          <p:cNvPicPr>
+            <a:picLocks noChangeAspect="1"/>
+          </p:cNvPicPr>
+          <p:nvPr/>
+        </p:nvPicPr>
+        <p:blipFill>
+          <a:blip r:embed="rId4"/>
+          <a:stretch>
+            <a:fillRect/>
+          </a:stretch>
+        </p:blipFill>
+        <p:spPr>
+          <a:xfrm>
+            <a:off x="612648" y="3749039"/>
+            <a:ext cx="4114800" cy="2313432"/>
+          </a:xfrm>
+          <a:prstGeom prst="rect">
+            <a:avLst/>
+          </a:prstGeom>
+        </p:spPr>
+      </p:pic>
+      <p:sp>
+        <p:nvSpPr>
+          <p:cNvPr id="17413" name="Rounded Rectangle 17412"/>
           <p:cNvSpPr/>
           <p:nvPr/>
         </p:nvSpPr>
         <p:spPr>
           <a:xfrm>
-            <a:off x="612648" y="3931920"/>
-            <a:ext cx="2606040" cy="2194560"/>
+            <a:off x="4892040" y="3749039"/>
+            <a:ext cx="3291840" cy="1115568"/>
           </a:xfrm>
           <a:prstGeom prst="roundRect">
             <a:avLst/>
@@ -12115,7 +11083,7 @@
           <a:solidFill>
             <a:srgbClr val="EFF6FF"/>
           </a:solidFill>
-          <a:ln w="15240">
+          <a:ln w="12700">
             <a:solidFill>
               <a:srgbClr val="2563EB"/>
             </a:solidFill>
@@ -12136,11 +11104,11 @@
           </a:fontRef>
         </p:style>
         <p:txBody>
-          <a:bodyPr rtlCol="0" anchor="ctr" wrap="square" lIns="109728" rIns="109728" tIns="73152"/>
+          <a:bodyPr rtlCol="0" anchor="ctr" wrap="square" lIns="73152" rIns="73152"/>
           <a:lstStyle/>
           <a:p>
             <a:pPr algn="ctr">
-              <a:defRPr sz="880" b="1">
+              <a:defRPr sz="800" b="1">
                 <a:solidFill>
                   <a:srgbClr val="2563EB"/>
                 </a:solidFill>
@@ -12154,11 +11122,11 @@
           <a:p>
             <a:pPr>
               <a:spcBef>
-                <a:spcPts val="250"/>
+                <a:spcPts val="150"/>
               </a:spcBef>
             </a:pPr>
             <a:r>
-              <a:rPr sz="750" b="1">
+              <a:rPr sz="680" b="1">
                 <a:solidFill>
                   <a:srgbClr val="0F172A"/>
                 </a:solidFill>
@@ -12167,7 +11135,7 @@
               <a:t>Source:</a:t>
             </a:r>
             <a:r>
-              <a:rPr sz="720">
+              <a:rPr sz="660">
                 <a:solidFill>
                   <a:srgbClr val="1E293B"/>
                 </a:solidFill>
@@ -12179,11 +11147,11 @@
           <a:p>
             <a:pPr>
               <a:spcBef>
-                <a:spcPts val="250"/>
+                <a:spcPts val="150"/>
               </a:spcBef>
             </a:pPr>
             <a:r>
-              <a:rPr sz="750" b="1">
+              <a:rPr sz="680" b="1">
                 <a:solidFill>
                   <a:srgbClr val="0F172A"/>
                 </a:solidFill>
@@ -12192,23 +11160,23 @@
               <a:t>Finding:</a:t>
             </a:r>
             <a:r>
-              <a:rPr sz="720">
+              <a:rPr sz="660">
                 <a:solidFill>
                   <a:srgbClr val="1E293B"/>
                 </a:solidFill>
                 <a:latin typeface="Arial"/>
               </a:rPr>
-              <a:t> Acute 79.9% shortfall of specialists at rural CHCs nationwide.</a:t>
+              <a:t> Acute 79.9% shortfall of specialists at rural CHCs.</a:t>
             </a:r>
           </a:p>
           <a:p>
             <a:pPr>
               <a:spcBef>
-                <a:spcPts val="250"/>
+                <a:spcPts val="150"/>
               </a:spcBef>
             </a:pPr>
             <a:r>
-              <a:rPr sz="750" b="1">
+              <a:rPr sz="680" b="1">
                 <a:solidFill>
                   <a:srgbClr val="0F172A"/>
                 </a:solidFill>
@@ -12217,27 +11185,27 @@
               <a:t>Relevance:</a:t>
             </a:r>
             <a:r>
-              <a:rPr sz="720">
+              <a:rPr sz="660">
                 <a:solidFill>
                   <a:srgbClr val="1E293B"/>
                 </a:solidFill>
                 <a:latin typeface="Arial"/>
               </a:rPr>
-              <a:t> Validates why capacity-aware routing is the only viable allocation mechanism.</a:t>
-            </a:r>
-          </a:p>
-        </p:txBody>
-      </p:sp>
-      <p:sp>
-        <p:nvSpPr>
-          <p:cNvPr id="17413" name="Rounded Rectangle 17412"/>
+              <a:t> Validates why capacity-aware routing is essential.</a:t>
+            </a:r>
+          </a:p>
+        </p:txBody>
+      </p:sp>
+      <p:sp>
+        <p:nvSpPr>
+          <p:cNvPr id="17414" name="Rounded Rectangle 17413"/>
           <p:cNvSpPr/>
           <p:nvPr/>
         </p:nvSpPr>
         <p:spPr>
           <a:xfrm>
-            <a:off x="3401568" y="3931920"/>
-            <a:ext cx="2606040" cy="2194560"/>
+            <a:off x="8293608" y="3749039"/>
+            <a:ext cx="3291840" cy="1115568"/>
           </a:xfrm>
           <a:prstGeom prst="roundRect">
             <a:avLst/>
@@ -12245,7 +11213,7 @@
           <a:solidFill>
             <a:srgbClr val="FEF2F2"/>
           </a:solidFill>
-          <a:ln w="15240">
+          <a:ln w="12700">
             <a:solidFill>
               <a:srgbClr val="E11D48"/>
             </a:solidFill>
@@ -12266,11 +11234,11 @@
           </a:fontRef>
         </p:style>
         <p:txBody>
-          <a:bodyPr rtlCol="0" anchor="ctr" wrap="square" lIns="109728" rIns="109728" tIns="73152"/>
+          <a:bodyPr rtlCol="0" anchor="ctr" wrap="square" lIns="73152" rIns="73152"/>
           <a:lstStyle/>
           <a:p>
             <a:pPr algn="ctr">
-              <a:defRPr sz="880" b="1">
+              <a:defRPr sz="800" b="1">
                 <a:solidFill>
                   <a:srgbClr val="E11D48"/>
                 </a:solidFill>
@@ -12284,11 +11252,11 @@
           <a:p>
             <a:pPr>
               <a:spcBef>
-                <a:spcPts val="250"/>
+                <a:spcPts val="150"/>
               </a:spcBef>
             </a:pPr>
             <a:r>
-              <a:rPr sz="750" b="1">
+              <a:rPr sz="680" b="1">
                 <a:solidFill>
                   <a:srgbClr val="0F172A"/>
                 </a:solidFill>
@@ -12297,7 +11265,7 @@
               <a:t>Source:</a:t>
             </a:r>
             <a:r>
-              <a:rPr sz="720">
+              <a:rPr sz="660">
                 <a:solidFill>
                   <a:srgbClr val="1E293B"/>
                 </a:solidFill>
@@ -12309,11 +11277,11 @@
           <a:p>
             <a:pPr>
               <a:spcBef>
-                <a:spcPts val="250"/>
+                <a:spcPts val="150"/>
               </a:spcBef>
             </a:pPr>
             <a:r>
-              <a:rPr sz="750" b="1">
+              <a:rPr sz="680" b="1">
                 <a:solidFill>
                   <a:srgbClr val="0F172A"/>
                 </a:solidFill>
@@ -12322,23 +11290,23 @@
               <a:t>Finding:</a:t>
             </a:r>
             <a:r>
-              <a:rPr sz="720">
+              <a:rPr sz="660">
                 <a:solidFill>
                   <a:srgbClr val="1E293B"/>
                 </a:solidFill>
                 <a:latin typeface="Arial"/>
               </a:rPr>
-              <a:t> 48.2% of referred primary patients never reach secondary hospitals.</a:t>
+              <a:t> 48.2% of referred primary patients never reach hospital.</a:t>
             </a:r>
           </a:p>
           <a:p>
             <a:pPr>
               <a:spcBef>
-                <a:spcPts val="250"/>
+                <a:spcPts val="150"/>
               </a:spcBef>
             </a:pPr>
             <a:r>
-              <a:rPr sz="750" b="1">
+              <a:rPr sz="680" b="1">
                 <a:solidFill>
                   <a:srgbClr val="0F172A"/>
                 </a:solidFill>
@@ -12347,27 +11315,27 @@
               <a:t>Relevance:</a:t>
             </a:r>
             <a:r>
-              <a:rPr sz="720">
+              <a:rPr sz="660">
                 <a:solidFill>
                   <a:srgbClr val="1E293B"/>
                 </a:solidFill>
                 <a:latin typeface="Arial"/>
               </a:rPr>
-              <a:t> Provides empirical baseline for SwasthyaSetu closed-loop tracking.</a:t>
-            </a:r>
-          </a:p>
-        </p:txBody>
-      </p:sp>
-      <p:sp>
-        <p:nvSpPr>
-          <p:cNvPr id="17414" name="Rounded Rectangle 17413"/>
+              <a:t> Direct empirical baseline for closed-loop tracking.</a:t>
+            </a:r>
+          </a:p>
+        </p:txBody>
+      </p:sp>
+      <p:sp>
+        <p:nvSpPr>
+          <p:cNvPr id="17415" name="Rounded Rectangle 17414"/>
           <p:cNvSpPr/>
           <p:nvPr/>
         </p:nvSpPr>
         <p:spPr>
           <a:xfrm>
-            <a:off x="6190488" y="3931920"/>
-            <a:ext cx="2606040" cy="2194560"/>
+            <a:off x="4892040" y="4946903"/>
+            <a:ext cx="3291840" cy="1115568"/>
           </a:xfrm>
           <a:prstGeom prst="roundRect">
             <a:avLst/>
@@ -12375,7 +11343,7 @@
           <a:solidFill>
             <a:srgbClr val="F8FAFC"/>
           </a:solidFill>
-          <a:ln w="15240">
+          <a:ln w="12700">
             <a:solidFill>
               <a:srgbClr val="0F172A"/>
             </a:solidFill>
@@ -12396,11 +11364,11 @@
           </a:fontRef>
         </p:style>
         <p:txBody>
-          <a:bodyPr rtlCol="0" anchor="ctr" wrap="square" lIns="109728" rIns="109728" tIns="73152"/>
+          <a:bodyPr rtlCol="0" anchor="ctr" wrap="square" lIns="73152" rIns="73152"/>
           <a:lstStyle/>
           <a:p>
             <a:pPr algn="ctr">
-              <a:defRPr sz="880" b="1">
+              <a:defRPr sz="800" b="1">
                 <a:solidFill>
                   <a:srgbClr val="0F172A"/>
                 </a:solidFill>
@@ -12414,11 +11382,11 @@
           <a:p>
             <a:pPr>
               <a:spcBef>
-                <a:spcPts val="250"/>
+                <a:spcPts val="150"/>
               </a:spcBef>
             </a:pPr>
             <a:r>
-              <a:rPr sz="750" b="1">
+              <a:rPr sz="680" b="1">
                 <a:solidFill>
                   <a:srgbClr val="0F172A"/>
                 </a:solidFill>
@@ -12427,7 +11395,7 @@
               <a:t>Source:</a:t>
             </a:r>
             <a:r>
-              <a:rPr sz="720">
+              <a:rPr sz="660">
                 <a:solidFill>
                   <a:srgbClr val="1E293B"/>
                 </a:solidFill>
@@ -12439,11 +11407,11 @@
           <a:p>
             <a:pPr>
               <a:spcBef>
-                <a:spcPts val="250"/>
+                <a:spcPts val="150"/>
               </a:spcBef>
             </a:pPr>
             <a:r>
-              <a:rPr sz="750" b="1">
+              <a:rPr sz="680" b="1">
                 <a:solidFill>
                   <a:srgbClr val="0F172A"/>
                 </a:solidFill>
@@ -12452,23 +11420,23 @@
               <a:t>Finding:</a:t>
             </a:r>
             <a:r>
-              <a:rPr sz="720">
+              <a:rPr sz="660">
                 <a:solidFill>
                   <a:srgbClr val="1E293B"/>
                 </a:solidFill>
                 <a:latin typeface="Arial"/>
               </a:rPr>
-              <a:t> OOPE accounts for 47.1% of health spend; pushes 55M into poverty.</a:t>
+              <a:t> OOPE is 47.1% of health spend; pushes 55M into debt.</a:t>
             </a:r>
           </a:p>
           <a:p>
             <a:pPr>
               <a:spcBef>
-                <a:spcPts val="250"/>
+                <a:spcPts val="150"/>
               </a:spcBef>
             </a:pPr>
             <a:r>
-              <a:rPr sz="750" b="1">
+              <a:rPr sz="680" b="1">
                 <a:solidFill>
                   <a:srgbClr val="0F172A"/>
                 </a:solidFill>
@@ -12477,27 +11445,27 @@
               <a:t>Relevance:</a:t>
             </a:r>
             <a:r>
-              <a:rPr sz="720">
+              <a:rPr sz="660">
                 <a:solidFill>
                   <a:srgbClr val="1E293B"/>
                 </a:solidFill>
                 <a:latin typeface="Arial"/>
               </a:rPr>
-              <a:t> Proves need for Coordinated One-Trip care to slash private transport costs.</a:t>
-            </a:r>
-          </a:p>
-        </p:txBody>
-      </p:sp>
-      <p:sp>
-        <p:nvSpPr>
-          <p:cNvPr id="17415" name="Rounded Rectangle 17414"/>
+              <a:t> Solved by Coordinated One-Trip Care Bundles.</a:t>
+            </a:r>
+          </a:p>
+        </p:txBody>
+      </p:sp>
+      <p:sp>
+        <p:nvSpPr>
+          <p:cNvPr id="17416" name="Rounded Rectangle 17415"/>
           <p:cNvSpPr/>
           <p:nvPr/>
         </p:nvSpPr>
         <p:spPr>
           <a:xfrm>
-            <a:off x="8979408" y="3931920"/>
-            <a:ext cx="2606040" cy="2194560"/>
+            <a:off x="8293608" y="4946903"/>
+            <a:ext cx="3291840" cy="1115568"/>
           </a:xfrm>
           <a:prstGeom prst="roundRect">
             <a:avLst/>
@@ -12505,7 +11473,7 @@
           <a:solidFill>
             <a:srgbClr val="F0FDFA"/>
           </a:solidFill>
-          <a:ln w="15240">
+          <a:ln w="12700">
             <a:solidFill>
               <a:srgbClr val="0D9488"/>
             </a:solidFill>
@@ -12526,11 +11494,11 @@
           </a:fontRef>
         </p:style>
         <p:txBody>
-          <a:bodyPr rtlCol="0" anchor="ctr" wrap="square" lIns="109728" rIns="109728" tIns="73152"/>
+          <a:bodyPr rtlCol="0" anchor="ctr" wrap="square" lIns="73152" rIns="73152"/>
           <a:lstStyle/>
           <a:p>
             <a:pPr algn="ctr">
-              <a:defRPr sz="880" b="1">
+              <a:defRPr sz="800" b="1">
                 <a:solidFill>
                   <a:srgbClr val="0D9488"/>
                 </a:solidFill>
@@ -12544,11 +11512,11 @@
           <a:p>
             <a:pPr>
               <a:spcBef>
-                <a:spcPts val="250"/>
+                <a:spcPts val="150"/>
               </a:spcBef>
             </a:pPr>
             <a:r>
-              <a:rPr sz="750" b="1">
+              <a:rPr sz="680" b="1">
                 <a:solidFill>
                   <a:srgbClr val="0F172A"/>
                 </a:solidFill>
@@ -12557,7 +11525,7 @@
               <a:t>Source:</a:t>
             </a:r>
             <a:r>
-              <a:rPr sz="720">
+              <a:rPr sz="660">
                 <a:solidFill>
                   <a:srgbClr val="1E293B"/>
                 </a:solidFill>
@@ -12569,11 +11537,11 @@
           <a:p>
             <a:pPr>
               <a:spcBef>
-                <a:spcPts val="250"/>
+                <a:spcPts val="150"/>
               </a:spcBef>
             </a:pPr>
             <a:r>
-              <a:rPr sz="750" b="1">
+              <a:rPr sz="680" b="1">
                 <a:solidFill>
                   <a:srgbClr val="0F172A"/>
                 </a:solidFill>
@@ -12582,23 +11550,23 @@
               <a:t>Finding:</a:t>
             </a:r>
             <a:r>
-              <a:rPr sz="720">
+              <a:rPr sz="660">
                 <a:solidFill>
                   <a:srgbClr val="1E293B"/>
                 </a:solidFill>
                 <a:latin typeface="Arial"/>
               </a:rPr>
-              <a:t> Bidirectional referral cuts transfer delay from 2.51 to 0.90 days.</a:t>
+              <a:t> Bidirectional referral cuts transfer delay to 0.90 days.</a:t>
             </a:r>
           </a:p>
           <a:p>
             <a:pPr>
               <a:spcBef>
-                <a:spcPts val="250"/>
+                <a:spcPts val="150"/>
               </a:spcBef>
             </a:pPr>
             <a:r>
-              <a:rPr sz="750" b="1">
+              <a:rPr sz="680" b="1">
                 <a:solidFill>
                   <a:srgbClr val="0F172A"/>
                 </a:solidFill>
@@ -12607,13 +11575,13 @@
               <a:t>Relevance:</a:t>
             </a:r>
             <a:r>
-              <a:rPr sz="720">
+              <a:rPr sz="660">
                 <a:solidFill>
                   <a:srgbClr val="1E293B"/>
                 </a:solidFill>
                 <a:latin typeface="Arial"/>
               </a:rPr>
-              <a:t> Core blueprint for SwasthyaSetu 3-way visibility &amp; ABHA integration.</a:t>
+              <a:t> Blueprint for SwasthyaSetu ABHA integration.</a:t>
             </a:r>
           </a:p>
         </p:txBody>

</xml_diff>